<commit_message>
move maturity model after operating model
</commit_message>
<xml_diff>
--- a/short/slides.pptx
+++ b/short/slides.pptx
@@ -30,6 +30,7 @@
     <p:sldId id="278" r:id="rId30"/>
     <p:sldId id="279" r:id="rId31"/>
     <p:sldId id="280" r:id="rId32"/>
+    <p:sldId id="281" r:id="rId33"/>
   </p:sldIdLst>
   <p:sldSz cx="12192000" cy="6858000" type="screen4x3"/>
   <p:notesSz cx="6858000" cy="9144000"/>
@@ -1591,22 +1592,122 @@
           <a:lstStyle/>
           <a:p>
             <a:r>
-              <a:t>- We have six blocks to cover in one hour - here is how we have structured the story</a:t>
-            </a:r>
-          </a:p>
-          <a:p>
-            <a:r>
-              <a:t>- The flow follows the four AgentOps pillars: evaluate the agent, ship with evidence, observe production behavior, and own the workload over time</a:t>
-            </a:r>
-          </a:p>
-          <a:p>
-            <a:r>
-              <a:t>- The session ends with a practical 30-day starting path</a:t>
+              <a:t>- We have seven blocks to cover in fifty minutes - here is how we have structured the story</a:t>
+            </a:r>
+          </a:p>
+          <a:p>
+            <a:r>
+              <a:t>- We start with Foundations - why agents need a new operating discipline, the four-pillar model, and where teams sit today</a:t>
+            </a:r>
+          </a:p>
+          <a:p>
+            <a:r>
+              <a:t>- Then a live demo showing the operating model on Foundry</a:t>
+            </a:r>
+          </a:p>
+          <a:p>
+            <a:r>
+              <a:t>- Then the four pillars themselves: evaluate, ship, observe, own</a:t>
+            </a:r>
+          </a:p>
+          <a:p>
+            <a:r>
+              <a:t>- We close with a practical 30-day adoption path</a:t>
+            </a:r>
+          </a:p>
+          <a:p>
+            <a:r>
+              <a:t>- Ten minutes reserved for Q&amp;A at the end</a:t>
             </a:r>
           </a:p>
           <a:p>
             <a:r>
               <a:t>- Let us start with Foundations</a:t>
+            </a:r>
+          </a:p>
+        </p:txBody>
+      </p:sp>
+      <p:sp>
+        <p:nvSpPr>
+          <p:cNvPr id="4" name="Slide Number Placeholder 3"/>
+          <p:cNvSpPr>
+            <a:spLocks noGrp="1"/>
+          </p:cNvSpPr>
+          <p:nvPr>
+            <p:ph type="sldNum" idx="5" sz="quarter"/>
+          </p:nvPr>
+        </p:nvSpPr>
+        <p:spPr/>
+      </p:sp>
+    </p:spTree>
+  </p:cSld>
+  <p:clrMapOvr>
+    <a:masterClrMapping/>
+  </p:clrMapOvr>
+</p:notes>
+</file>
+
+<file path=ppt/notesSlides/notesSlide20.xml><?xml version="1.0" encoding="utf-8"?>
+<p:notes xmlns:a="http://schemas.openxmlformats.org/drawingml/2006/main" xmlns:p="http://schemas.openxmlformats.org/presentationml/2006/main" xmlns:r="http://schemas.openxmlformats.org/officeDocument/2006/relationships">
+  <p:cSld>
+    <p:spTree>
+      <p:nvGrpSpPr>
+        <p:cNvPr id="1" name=""/>
+        <p:cNvGrpSpPr/>
+        <p:nvPr/>
+      </p:nvGrpSpPr>
+      <p:grpSpPr>
+        <a:xfrm>
+          <a:off x="0" y="0"/>
+          <a:ext cx="0" cy="0"/>
+          <a:chOff x="0" y="0"/>
+          <a:chExt cx="0" cy="0"/>
+        </a:xfrm>
+      </p:grpSpPr>
+      <p:sp>
+        <p:nvSpPr>
+          <p:cNvPr id="2" name="Slide Image Placeholder 1"/>
+          <p:cNvSpPr>
+            <a:spLocks noGrp="1"/>
+          </p:cNvSpPr>
+          <p:nvPr>
+            <p:ph type="sldImg" idx="2"/>
+          </p:nvPr>
+        </p:nvSpPr>
+        <p:spPr/>
+      </p:sp>
+      <p:sp>
+        <p:nvSpPr>
+          <p:cNvPr id="3" name="Notes Placeholder 2"/>
+          <p:cNvSpPr>
+            <a:spLocks noGrp="1"/>
+          </p:cNvSpPr>
+          <p:nvPr>
+            <p:ph type="body" idx="3" sz="quarter"/>
+          </p:nvPr>
+        </p:nvSpPr>
+        <p:spPr/>
+        <p:txBody>
+          <a:bodyPr/>
+          <a:lstStyle/>
+          <a:p>
+            <a:r>
+              <a:t>- Thank you for your time today</a:t>
+            </a:r>
+          </a:p>
+          <a:p>
+            <a:r>
+              <a:t>- We have ten minutes for questions</a:t>
+            </a:r>
+          </a:p>
+          <a:p>
+            <a:r>
+              <a:t>- Happy to go deeper on any of the pillars - evaluation datasets, CI/CD gate design, observability correlation, or Day-2 operations</a:t>
+            </a:r>
+          </a:p>
+          <a:p>
+            <a:r>
+              <a:t>- If you want to continue the conversation, reach out to your account team or find us after the session</a:t>
             </a:r>
           </a:p>
         </p:txBody>
@@ -1981,7 +2082,7 @@
           </a:p>
           <a:p>
             <a:r>
-              <a:t>- But where does your team sit today against this checklist? The maturity model helps you locate yourself</a:t>
+              <a:t>- Now let us see the operating model that connects these items into a repeatable process</a:t>
             </a:r>
           </a:p>
         </p:txBody>
@@ -2051,37 +2152,47 @@
           <a:lstStyle/>
           <a:p>
             <a:r>
-              <a:t>- The checklist defines what good looks like - the maturity model tells you where you are today</a:t>
-            </a:r>
-          </a:p>
-          <a:p>
-            <a:r>
-              <a:t>- Initial: ad hoc demos, manual eval, no gates, scattered logs</a:t>
-            </a:r>
-          </a:p>
-          <a:p>
-            <a:r>
-              <a:t>- Defined: versioned prompts and agents, pre-prod eval datasets, CI builds artefacts</a:t>
-            </a:r>
-          </a:p>
-          <a:p>
-            <a:r>
-              <a:t>- Managed: quality and safety gates in CI, continuous evaluation in production, runbooks and SLOs</a:t>
-            </a:r>
-          </a:p>
-          <a:p>
-            <a:r>
-              <a:t>- Optimised: drift and cost guardrails, canary plus auto-rollback, feedback flywheel</a:t>
-            </a:r>
-          </a:p>
-          <a:p>
-            <a:r>
-              <a:t>- The practical move is not to boil the ocean - pick one production-candidate agent and move it up one level</a:t>
-            </a:r>
-          </a:p>
-          <a:p>
-            <a:r>
-              <a:t>- The question is: how do we produce this evidence repeatably, every release, without heroics? That is what the operating model gives us</a:t>
+              <a:t>- The checklist tells us what evidence we need. The operating model tells us how to apply it across the agent lifecycle</a:t>
+            </a:r>
+          </a:p>
+          <a:p>
+            <a:r>
+              <a:t>- AgentOps applies DevOps discipline to AI agents, where behavior is probabilistic and releases need evidence</a:t>
+            </a:r>
+          </a:p>
+          <a:p>
+            <a:r>
+              <a:t>- The model has four pillars:</a:t>
+            </a:r>
+          </a:p>
+          <a:p>
+            <a:r>
+              <a:t>- Evaluate pre-production behavior using golden datasets, rubrics, red teaming, and thresholds</a:t>
+            </a:r>
+          </a:p>
+          <a:p>
+            <a:r>
+              <a:t>- Ship with CI/CD gates, release evidence, human approvals, environment promotion, and canary</a:t>
+            </a:r>
+          </a:p>
+          <a:p>
+            <a:r>
+              <a:t>- Observe production behavior through traces, metrics, logs, content safety signals, feedback, cost, and latency</a:t>
+            </a:r>
+          </a:p>
+          <a:p>
+            <a:r>
+              <a:t>- Own the workload through diagnosis, incident response, runbooks, model lifecycle, cost management, capacity management, and continuous improvement</a:t>
+            </a:r>
+          </a:p>
+          <a:p>
+            <a:r>
+              <a:t>- The output is release evidence and operational confidence</a:t>
+            </a:r>
+          </a:p>
+          <a:p>
+            <a:r>
+              <a:t>- Now that we know the model, the question is: where does your team sit today?</a:t>
             </a:r>
           </a:p>
         </p:txBody>
@@ -2151,42 +2262,32 @@
           <a:lstStyle/>
           <a:p>
             <a:r>
-              <a:t>- The checklist tells us what evidence we need. The operating model tells us how to apply it across the agent lifecycle</a:t>
-            </a:r>
-          </a:p>
-          <a:p>
-            <a:r>
-              <a:t>- AgentOps applies DevOps discipline to AI agents, where behavior is probabilistic and releases need evidence</a:t>
-            </a:r>
-          </a:p>
-          <a:p>
-            <a:r>
-              <a:t>- The model has four pillars:</a:t>
-            </a:r>
-          </a:p>
-          <a:p>
-            <a:r>
-              <a:t>- Evaluate pre-production behavior using golden datasets, rubrics, red teaming, and thresholds</a:t>
-            </a:r>
-          </a:p>
-          <a:p>
-            <a:r>
-              <a:t>- Ship with CI/CD gates, release evidence, human approvals, environment promotion, and canary</a:t>
-            </a:r>
-          </a:p>
-          <a:p>
-            <a:r>
-              <a:t>- Observe production behavior through traces, metrics, logs, content safety signals, feedback, cost, and latency</a:t>
-            </a:r>
-          </a:p>
-          <a:p>
-            <a:r>
-              <a:t>- Own the workload through diagnosis, incident response, runbooks, model lifecycle, cost management, capacity management, and continuous improvement</a:t>
-            </a:r>
-          </a:p>
-          <a:p>
-            <a:r>
-              <a:t>- The output is release evidence and operational confidence</a:t>
+              <a:t>- The checklist defines what good looks like. The operating model tells you how to get there. The maturity model tells you where you are today</a:t>
+            </a:r>
+          </a:p>
+          <a:p>
+            <a:r>
+              <a:t>- Initial: ad hoc demos, manual eval, no gates, scattered logs</a:t>
+            </a:r>
+          </a:p>
+          <a:p>
+            <a:r>
+              <a:t>- Defined: versioned prompts and agents, pre-prod eval datasets, CI builds artefacts</a:t>
+            </a:r>
+          </a:p>
+          <a:p>
+            <a:r>
+              <a:t>- Managed: quality and safety gates in CI, continuous evaluation in production, runbooks and SLOs</a:t>
+            </a:r>
+          </a:p>
+          <a:p>
+            <a:r>
+              <a:t>- Optimised: drift and cost guardrails, canary plus auto-rollback, feedback flywheel</a:t>
+            </a:r>
+          </a:p>
+          <a:p>
+            <a:r>
+              <a:t>- The practical move is not to boil the ocean - pick one production-candidate agent and move it up one level</a:t>
             </a:r>
           </a:p>
           <a:p>
@@ -6504,6 +6605,40 @@
                 <a:latin typeface="Segoe UI"/>
               </a:rPr>
               <a:t> - why AI ops is different and the four-pillar model</a:t>
+            </a:r>
+          </a:p>
+          <a:p>
+            <a:pPr>
+              <a:spcAft>
+                <a:spcPts val="400"/>
+              </a:spcAft>
+            </a:pPr>
+            <a:r>
+              <a:rPr sz="1600">
+                <a:solidFill>
+                  <a:srgbClr val="091F2C"/>
+                </a:solidFill>
+                <a:latin typeface="Segoe UI"/>
+              </a:rPr>
+              <a:t>• </a:t>
+            </a:r>
+            <a:r>
+              <a:rPr sz="1600" b="1">
+                <a:solidFill>
+                  <a:srgbClr val="091F2C"/>
+                </a:solidFill>
+                <a:latin typeface="Segoe UI"/>
+              </a:rPr>
+              <a:t>Demo</a:t>
+            </a:r>
+            <a:r>
+              <a:rPr sz="1600" b="0">
+                <a:solidFill>
+                  <a:srgbClr val="091F2C"/>
+                </a:solidFill>
+                <a:latin typeface="Segoe UI"/>
+              </a:rPr>
+              <a:t> - the operating model in action on Foundry</a:t>
             </a:r>
           </a:p>
           <a:p>
@@ -7895,6 +8030,58 @@
 </p:sld>
 </file>
 
+<file path=ppt/slides/slide26.xml><?xml version="1.0" encoding="utf-8"?>
+<p:sld xmlns:a="http://schemas.openxmlformats.org/drawingml/2006/main" xmlns:p="http://schemas.openxmlformats.org/presentationml/2006/main" xmlns:r="http://schemas.openxmlformats.org/officeDocument/2006/relationships">
+  <p:cSld>
+    <p:spTree>
+      <p:nvGrpSpPr>
+        <p:cNvPr id="1" name=""/>
+        <p:cNvGrpSpPr/>
+        <p:nvPr/>
+      </p:nvGrpSpPr>
+      <p:grpSpPr/>
+      <p:sp>
+        <p:nvSpPr>
+          <p:cNvPr id="2" name="TextBox 1"/>
+          <p:cNvSpPr txBox="1"/>
+          <p:nvPr/>
+        </p:nvSpPr>
+        <p:spPr>
+          <a:xfrm>
+            <a:off x="588263" y="457200"/>
+            <a:ext cx="11018520" cy="553998"/>
+          </a:xfrm>
+          <a:prstGeom prst="rect">
+            <a:avLst/>
+          </a:prstGeom>
+          <a:noFill/>
+        </p:spPr>
+        <p:txBody>
+          <a:bodyPr wrap="square">
+            <a:spAutoFit/>
+          </a:bodyPr>
+          <a:lstStyle/>
+          <a:p>
+            <a:r>
+              <a:rPr sz="3600" b="0">
+                <a:solidFill>
+                  <a:srgbClr val="091F2C"/>
+                </a:solidFill>
+                <a:latin typeface="Segoe UI Semibold"/>
+              </a:rPr>
+              <a:t>Thank You</a:t>
+            </a:r>
+          </a:p>
+        </p:txBody>
+      </p:sp>
+    </p:spTree>
+  </p:cSld>
+  <p:clrMapOvr>
+    <a:masterClrMapping/>
+  </p:clrMapOvr>
+</p:sld>
+</file>
+
 <file path=ppt/slides/slide3.xml><?xml version="1.0" encoding="utf-8"?>
 <p:sld xmlns:a="http://schemas.openxmlformats.org/drawingml/2006/main" xmlns:p="http://schemas.openxmlformats.org/presentationml/2006/main" xmlns:r="http://schemas.openxmlformats.org/officeDocument/2006/relationships">
   <p:cSld>
@@ -8636,7 +8823,7 @@
                 </a:solidFill>
                 <a:latin typeface="Segoe UI Semibold"/>
               </a:rPr>
-              <a:t>Maturity model</a:t>
+              <a:t>AgentOps operating model</a:t>
             </a:r>
           </a:p>
         </p:txBody>
@@ -8670,14 +8857,14 @@
                 </a:solidFill>
                 <a:latin typeface="Segoe UI"/>
               </a:rPr>
-              <a:t>Most teams sit between Initial and Defined - start by moving one production-candidate agent up one level</a:t>
+              <a:t>Four pillars - Evaluate, ship, observe, and own production agents</a:t>
             </a:r>
           </a:p>
         </p:txBody>
       </p:sp>
       <p:pic>
         <p:nvPicPr>
-          <p:cNvPr id="4" name="AgentOps maturity ribbon with four levels: Initial, Defined, Managed, Optimised" descr="AgentOps maturity ribbon with four levels: Initial, Defined, Managed, Optimised"/>
+          <p:cNvPr id="4" name="Four AgentOps pillars: Evaluate, Ship, Observe, Own, with example practices under each pillar" descr="Four AgentOps pillars: Evaluate, Ship, Observe, Own, with example practices under each pillar"/>
           <p:cNvPicPr>
             <a:picLocks noChangeAspect="1"/>
           </p:cNvPicPr>
@@ -8746,7 +8933,7 @@
                 </a:solidFill>
                 <a:latin typeface="Segoe UI Semibold"/>
               </a:rPr>
-              <a:t>AgentOps operating model</a:t>
+              <a:t>Maturity model</a:t>
             </a:r>
           </a:p>
         </p:txBody>
@@ -8780,14 +8967,14 @@
                 </a:solidFill>
                 <a:latin typeface="Segoe UI"/>
               </a:rPr>
-              <a:t>Four pillars - Evaluate, ship, observe, and own production agents</a:t>
+              <a:t>Most teams sit between Initial and Defined - start by moving one production-candidate agent up one level</a:t>
             </a:r>
           </a:p>
         </p:txBody>
       </p:sp>
       <p:pic>
         <p:nvPicPr>
-          <p:cNvPr id="4" name="Four AgentOps pillars: Evaluate, Ship, Observe, Own, with example practices under each pillar" descr="Four AgentOps pillars: Evaluate, Ship, Observe, Own, with example practices under each pillar"/>
+          <p:cNvPr id="4" name="AgentOps maturity ribbon with four levels: Initial, Defined, Managed, Optimised" descr="AgentOps maturity ribbon with four levels: Initial, Defined, Managed, Optimised"/>
           <p:cNvPicPr>
             <a:picLocks noChangeAspect="1"/>
           </p:cNvPicPr>

</xml_diff>

<commit_message>
include demo slides and minor changes to last adoption slide, updates to speaker transcript to folllow changes
</commit_message>
<xml_diff>
--- a/short/slides.pptx
+++ b/short/slides.pptx
@@ -31,6 +31,9 @@
     <p:sldId id="279" r:id="rId31"/>
     <p:sldId id="280" r:id="rId32"/>
     <p:sldId id="281" r:id="rId33"/>
+    <p:sldId id="282" r:id="rId34"/>
+    <p:sldId id="283" r:id="rId35"/>
+    <p:sldId id="284" r:id="rId36"/>
   </p:sldIdLst>
   <p:sldSz cx="12192000" cy="6858000" type="screen4x3"/>
   <p:notesSz cx="6858000" cy="9144000"/>
@@ -617,12 +620,42 @@
           <a:lstStyle/>
           <a:p>
             <a:r>
-              <a:t>- Live demo or recorded walkthrough showing the AgentOps operating model in practice</a:t>
-            </a:r>
-          </a:p>
-          <a:p>
-            <a:r>
-              <a:t>- Walk through the inner loop, evaluation, gating, and observability on Foundry</a:t>
+              <a:t>- This is the Evaluate pillar. Without a quality signal, there is nothing to ship with confidence</a:t>
+            </a:r>
+          </a:p>
+          <a:p>
+            <a:r>
+              <a:t>- Start with a small golden dataset tied to real user journeys</a:t>
+            </a:r>
+          </a:p>
+          <a:p>
+            <a:r>
+              <a:t>- Evaluate quality, groundedness, latency, cost, and behavior. Compare against baselines and previous versions</a:t>
+            </a:r>
+          </a:p>
+          <a:p>
+            <a:r>
+              <a:t>- Promote reviewed production traces into future regression cases</a:t>
+            </a:r>
+          </a:p>
+          <a:p>
+            <a:r>
+              <a:t>- A few dozen representative cases beat zero cases</a:t>
+            </a:r>
+          </a:p>
+          <a:p>
+            <a:r>
+              <a:t>- Use Foundry's built-in evaluators for quality, groundedness, and agent metrics like intent resolution and tool call accuracy</a:t>
+            </a:r>
+          </a:p>
+          <a:p>
+            <a:r>
+              <a:t>- The eval dataset is a living artifact - every reviewed production trace can become a new test row</a:t>
+            </a:r>
+          </a:p>
+          <a:p>
+            <a:r>
+              <a:t>- But quality evaluation alone is not enough - we also need to test adversarial scenarios</a:t>
             </a:r>
           </a:p>
         </p:txBody>
@@ -692,42 +725,42 @@
           <a:lstStyle/>
           <a:p>
             <a:r>
-              <a:t>- This is the Evaluate pillar. Without a quality signal, there is nothing to ship with confidence</a:t>
-            </a:r>
-          </a:p>
-          <a:p>
-            <a:r>
-              <a:t>- Start with a small golden dataset tied to real user journeys</a:t>
-            </a:r>
-          </a:p>
-          <a:p>
-            <a:r>
-              <a:t>- Evaluate quality, groundedness, latency, cost, and behavior. Compare against baselines and previous versions</a:t>
-            </a:r>
-          </a:p>
-          <a:p>
-            <a:r>
-              <a:t>- Promote reviewed production traces into future regression cases</a:t>
-            </a:r>
-          </a:p>
-          <a:p>
-            <a:r>
-              <a:t>- A few dozen representative cases beat zero cases</a:t>
-            </a:r>
-          </a:p>
-          <a:p>
-            <a:r>
-              <a:t>- Use Foundry's built-in evaluators for quality, groundedness, and agent metrics like intent resolution and tool call accuracy</a:t>
-            </a:r>
-          </a:p>
-          <a:p>
-            <a:r>
-              <a:t>- The eval dataset is a living artifact - every reviewed production trace can become a new test row</a:t>
-            </a:r>
-          </a:p>
-          <a:p>
-            <a:r>
-              <a:t>- But quality evaluation alone is not enough - we also need to test adversarial scenarios</a:t>
+              <a:t>- Quality evaluation tells us if the answer is good - but it will not tell us if someone can make the agent misbehave. That is red teaming</a:t>
+            </a:r>
+          </a:p>
+          <a:p>
+            <a:r>
+              <a:t>- Safety and quality are different signals - quality scoring will not catch a jailbreak</a:t>
+            </a:r>
+          </a:p>
+          <a:p>
+            <a:r>
+              <a:t>- Foundry ships an AI Red Teaming Agent backed by Microsoft's PyRIT framework for automated adversarial testing</a:t>
+            </a:r>
+          </a:p>
+          <a:p>
+            <a:r>
+              <a:t>- Four risk categories: harmful content, jailbreak (prompt injection, role hijacking), hallucination (ungrounded claims), data exfiltration (PII leakage, tool abuse)</a:t>
+            </a:r>
+          </a:p>
+          <a:p>
+            <a:r>
+              <a:t>- Cadence: pre-release gate, scheduled weekly, post-incident</a:t>
+            </a:r>
+          </a:p>
+          <a:p>
+            <a:r>
+              <a:t>- Findings feed the eval dataset as adversarial rows for future regression coverage</a:t>
+            </a:r>
+          </a:p>
+          <a:p>
+            <a:r>
+              <a:t>- New at Build 2026: Adaptive Evaluations (preview) convert safety and governance policies directly into automated tests. Paired with ASSERT (Agent Security and Safety Evaluation Run-Time), teams can turn policies into repeatable eval coverage without hand-writing every test case</a:t>
+            </a:r>
+          </a:p>
+          <a:p>
+            <a:r>
+              <a:t>- Now that we have evaluation and red teaming producing signals, how do we enforce them? That brings us to Ship</a:t>
             </a:r>
           </a:p>
         </p:txBody>
@@ -797,42 +830,7 @@
           <a:lstStyle/>
           <a:p>
             <a:r>
-              <a:t>- Quality evaluation tells us if the answer is good - but it will not tell us if someone can make the agent misbehave. That is red teaming</a:t>
-            </a:r>
-          </a:p>
-          <a:p>
-            <a:r>
-              <a:t>- Safety and quality are different signals - quality scoring will not catch a jailbreak</a:t>
-            </a:r>
-          </a:p>
-          <a:p>
-            <a:r>
-              <a:t>- Foundry ships an AI Red Teaming Agent backed by Microsoft's PyRIT framework for automated adversarial testing</a:t>
-            </a:r>
-          </a:p>
-          <a:p>
-            <a:r>
-              <a:t>- Four risk categories: harmful content, jailbreak (prompt injection, role hijacking), hallucination (ungrounded claims), data exfiltration (PII leakage, tool abuse)</a:t>
-            </a:r>
-          </a:p>
-          <a:p>
-            <a:r>
-              <a:t>- Cadence: pre-release gate, scheduled weekly, post-incident</a:t>
-            </a:r>
-          </a:p>
-          <a:p>
-            <a:r>
-              <a:t>- Findings feed the eval dataset as adversarial rows for future regression coverage</a:t>
-            </a:r>
-          </a:p>
-          <a:p>
-            <a:r>
-              <a:t>- New at Build 2026: Adaptive Evaluations (preview) convert safety and governance policies directly into automated tests. Paired with ASSERT (Agent Security and Safety Evaluation Run-Time), teams can turn policies into repeatable eval coverage without hand-writing every test case</a:t>
-            </a:r>
-          </a:p>
-          <a:p>
-            <a:r>
-              <a:t>- Now that we have evaluation and red teaming producing signals, how do we enforce them? That brings us to Ship</a:t>
+              <a:t>- Live demo showing evaluation in action on Foundry: golden dataset, evaluator runs, score comparison, and the release signal</a:t>
             </a:r>
           </a:p>
         </p:txBody>
@@ -1002,32 +1000,7 @@
           <a:lstStyle/>
           <a:p>
             <a:r>
-              <a:t>- This is the Observe pillar. Gates enforce quality before release, but once the agent is live we need to understand what it is doing and why</a:t>
-            </a:r>
-          </a:p>
-          <a:p>
-            <a:r>
-              <a:t>- For agents, the unit of understanding is the trace - the chain of decisions, not just the endpoint status</a:t>
-            </a:r>
-          </a:p>
-          <a:p>
-            <a:r>
-              <a:t>- Required signals: prompt, plan, model call, retrieval, tool call, safety event, latency, cost, user feedback, release version</a:t>
-            </a:r>
-          </a:p>
-          <a:p>
-            <a:r>
-              <a:t>- Required correlation: trace ID, session ID, agent version, deployment, eval run, incident, owner</a:t>
-            </a:r>
-          </a:p>
-          <a:p>
-            <a:r>
-              <a:t>- Without correlation, observability is just disconnected dashboards. With it, the same trace answers questions across release, runtime, evaluation, and Day-2</a:t>
-            </a:r>
-          </a:p>
-          <a:p>
-            <a:r>
-              <a:t>- But signals alone are not the goal - what matters is what you do with them</a:t>
+              <a:t>- Live demo showing CI/CD gates in action: pipeline build, evaluation gate, failed gate blocking a regression, evidence artifact</a:t>
             </a:r>
           </a:p>
         </p:txBody>
@@ -1097,47 +1070,32 @@
           <a:lstStyle/>
           <a:p>
             <a:r>
-              <a:t>- Collecting signals is not the end goal - what matters is turning them into action. This slide is the connective tissue of the whole session</a:t>
-            </a:r>
-          </a:p>
-          <a:p>
-            <a:r>
-              <a:t>- A trace explains a failure. A reviewed trace becomes a new eval row. The eval row enters the gate. The gate prevents recurrence</a:t>
-            </a:r>
-          </a:p>
-          <a:p>
-            <a:r>
-              <a:t>- Latency spike -&gt; Azure Monitor alert -&gt; on-call</a:t>
-            </a:r>
-          </a:p>
-          <a:p>
-            <a:r>
-              <a:t>- Tool error rate -&gt; disable tool, fall back to manual</a:t>
-            </a:r>
-          </a:p>
-          <a:p>
-            <a:r>
-              <a:t>- Safety violation -&gt; block plus content safety incident</a:t>
-            </a:r>
-          </a:p>
-          <a:p>
-            <a:r>
-              <a:t>- Eval score drop -&gt; pause canary, open ticket</a:t>
-            </a:r>
-          </a:p>
-          <a:p>
-            <a:r>
-              <a:t>- Cost anomaly -&gt; throttle via APIM, notify FinOps</a:t>
-            </a:r>
-          </a:p>
-          <a:p>
-            <a:r>
-              <a:t>- Positive feedback -&gt; sample into eval dataset</a:t>
-            </a:r>
-          </a:p>
-          <a:p>
-            <a:r>
-              <a:t>- This is how Observe feeds Own, and how Own feeds the next Evaluate and Ship cycle</a:t>
+              <a:t>- This is the Observe pillar. Gates enforce quality before release, but once the agent is live we need to understand what it is doing and why</a:t>
+            </a:r>
+          </a:p>
+          <a:p>
+            <a:r>
+              <a:t>- For agents, the unit of understanding is the trace - the chain of decisions, not just the endpoint status</a:t>
+            </a:r>
+          </a:p>
+          <a:p>
+            <a:r>
+              <a:t>- Required signals: prompt, plan, model call, retrieval, tool call, safety event, latency, cost, user feedback, release version</a:t>
+            </a:r>
+          </a:p>
+          <a:p>
+            <a:r>
+              <a:t>- Required correlation: trace ID, session ID, agent version, deployment, eval run, incident, owner</a:t>
+            </a:r>
+          </a:p>
+          <a:p>
+            <a:r>
+              <a:t>- Without correlation, observability is just disconnected dashboards. With it, the same trace answers questions across release, runtime, evaluation, and Day-2</a:t>
+            </a:r>
+          </a:p>
+          <a:p>
+            <a:r>
+              <a:t>- But signals alone are not the goal - what matters is what you do with them</a:t>
             </a:r>
           </a:p>
         </p:txBody>
@@ -1207,42 +1165,47 @@
           <a:lstStyle/>
           <a:p>
             <a:r>
-              <a:t>- This is the Own pillar. Shipping is not the finish line, it is where the real operational work begins. Day-2 has four concerns teams need to own</a:t>
-            </a:r>
-          </a:p>
-          <a:p>
-            <a:r>
-              <a:t>- Reliability and SLOs: availability, latency, error rate budgets; tool dependency failure modes; graceful degradation</a:t>
-            </a:r>
-          </a:p>
-          <a:p>
-            <a:r>
-              <a:t>- Incident response: runbooks per severity; on-call rotation that knows the agent; postmortems with model plus prompt context</a:t>
-            </a:r>
-          </a:p>
-          <a:p>
-            <a:r>
-              <a:t>- Model lifecycle: canary rollout for upgrades; prompt and tool versioned alongside model; rollback drills</a:t>
-            </a:r>
-          </a:p>
-          <a:p>
-            <a:r>
-              <a:t>- Cost and capacity: PTU vs pay-as-you-go; token and tool call budgets per tenant; alerting on cost anomalies</a:t>
-            </a:r>
-          </a:p>
-          <a:p>
-            <a:r>
-              <a:t>- The four concerns are interlocking - each creates signals that feed back into evaluation and the next release</a:t>
-            </a:r>
-          </a:p>
-          <a:p>
-            <a:r>
-              <a:t>- Governance umbrella: Microsoft Agent 365 (GA May 2026) provides the observe, govern, and secure control plane across all agents in the enterprise. The SDK is free and framework-agnostic - works with Microsoft Agent Framework, OpenAI Agents SDK, LangChain, Semantic Kernel. Brings custom and third-party agents under one governance umbrella so Day-2 visibility and policy enforcement are consistent</a:t>
-            </a:r>
-          </a:p>
-          <a:p>
-            <a:r>
-              <a:t>- The next two slides go deeper into incident response and model lifecycle</a:t>
+              <a:t>- Collecting signals is not the end goal - what matters is turning them into action. This slide is the connective tissue of the whole session</a:t>
+            </a:r>
+          </a:p>
+          <a:p>
+            <a:r>
+              <a:t>- A trace explains a failure. A reviewed trace becomes a new eval row. The eval row enters the gate. The gate prevents recurrence</a:t>
+            </a:r>
+          </a:p>
+          <a:p>
+            <a:r>
+              <a:t>- Latency spike -&gt; Azure Monitor alert -&gt; on-call</a:t>
+            </a:r>
+          </a:p>
+          <a:p>
+            <a:r>
+              <a:t>- Tool error rate -&gt; disable tool, fall back to manual</a:t>
+            </a:r>
+          </a:p>
+          <a:p>
+            <a:r>
+              <a:t>- Safety violation -&gt; block plus content safety incident</a:t>
+            </a:r>
+          </a:p>
+          <a:p>
+            <a:r>
+              <a:t>- Eval score drop -&gt; pause canary, open ticket</a:t>
+            </a:r>
+          </a:p>
+          <a:p>
+            <a:r>
+              <a:t>- Cost anomaly -&gt; throttle via APIM, notify FinOps</a:t>
+            </a:r>
+          </a:p>
+          <a:p>
+            <a:r>
+              <a:t>- Positive feedback -&gt; sample into eval dataset</a:t>
+            </a:r>
+          </a:p>
+          <a:p>
+            <a:r>
+              <a:t>- This is how Observe feeds Own, and how Own feeds the next Evaluate and Ship cycle</a:t>
             </a:r>
           </a:p>
         </p:txBody>
@@ -1312,32 +1275,7 @@
           <a:lstStyle/>
           <a:p>
             <a:r>
-              <a:t>- When something goes wrong in production, you need a structured response - not a fire drill. The runbook turns chaos into a sequence</a:t>
-            </a:r>
-          </a:p>
-          <a:p>
-            <a:r>
-              <a:t>- The severity table sets expectations so teams do not over-react or under-react</a:t>
-            </a:r>
-          </a:p>
-          <a:p>
-            <a:r>
-              <a:t>- The triage flow makes containment explicit - stop the bleed before debugging</a:t>
-            </a:r>
-          </a:p>
-          <a:p>
-            <a:r>
-              <a:t>- The runbook is part of Own because it turns production signals into containment, evidence-backed fixes, and future evaluation coverage</a:t>
-            </a:r>
-          </a:p>
-          <a:p>
-            <a:r>
-              <a:t>- Every closed incident produces evidence that updates the eval dataset, the gate criteria, or the operating model</a:t>
-            </a:r>
-          </a:p>
-          <a:p>
-            <a:r>
-              <a:t>- The other recurring Day-2 challenge is model lifecycle - let us look at that next</a:t>
+              <a:t>- Live demo showing observability in action: trace waterfall, correlated spans, continuous evaluation scores, and signal-to-action flow</a:t>
             </a:r>
           </a:p>
         </p:txBody>
@@ -1407,42 +1345,42 @@
           <a:lstStyle/>
           <a:p>
             <a:r>
-              <a:t>- When the model itself changes - deprecation, new versions, cost pressure - that is model lifecycle. The recurring pain point: "the model we depend on is being deprecated, what now?"</a:t>
-            </a:r>
-          </a:p>
-          <a:p>
-            <a:r>
-              <a:t>- The answer: same gates and evidence as any other release candidate</a:t>
-            </a:r>
-          </a:p>
-          <a:p>
-            <a:r>
-              <a:t>- Triggers: deprecation, new model availability, cost or performance pressure, vendor change</a:t>
-            </a:r>
-          </a:p>
-          <a:p>
-            <a:r>
-              <a:t>- Canary process: pin current model as baseline; run new model against eval dataset offline; promote to canary traffic slice; compare live quality, cost, latency, safety; roll forward or roll back with evidence</a:t>
-            </a:r>
-          </a:p>
-          <a:p>
-            <a:r>
-              <a:t>- Ownership: AI platform team coordinates, application team validates</a:t>
-            </a:r>
-          </a:p>
-          <a:p>
-            <a:r>
-              <a:t>- Model lifecycle is part of Own because every model, prompt, or tool change becomes a new release candidate that must go back through Evaluate and Ship</a:t>
-            </a:r>
-          </a:p>
-          <a:p>
-            <a:r>
-              <a:t>- Canary upgrades map cleanly to model changes if the eval dataset and release contract are already in place</a:t>
-            </a:r>
-          </a:p>
-          <a:p>
-            <a:r>
-              <a:t>- We have covered the full loop - now the question is: where do you start?</a:t>
+              <a:t>- This is the Own pillar. Shipping is not the finish line, it is where the real operational work begins. Day-2 has four concerns teams need to own</a:t>
+            </a:r>
+          </a:p>
+          <a:p>
+            <a:r>
+              <a:t>- Reliability and SLOs: availability, latency, error rate budgets; tool dependency failure modes; graceful degradation</a:t>
+            </a:r>
+          </a:p>
+          <a:p>
+            <a:r>
+              <a:t>- Incident response: runbooks per severity; on-call rotation that knows the agent; postmortems with model plus prompt context</a:t>
+            </a:r>
+          </a:p>
+          <a:p>
+            <a:r>
+              <a:t>- Model lifecycle: canary rollout for upgrades; prompt and tool versioned alongside model; rollback drills</a:t>
+            </a:r>
+          </a:p>
+          <a:p>
+            <a:r>
+              <a:t>- Cost and capacity: PTU vs pay-as-you-go; token and tool call budgets per tenant; alerting on cost anomalies</a:t>
+            </a:r>
+          </a:p>
+          <a:p>
+            <a:r>
+              <a:t>- The four concerns are interlocking - each creates signals that feed back into evaluation and the next release</a:t>
+            </a:r>
+          </a:p>
+          <a:p>
+            <a:r>
+              <a:t>- Governance umbrella: Microsoft Agent 365 (GA May 2026) provides the observe, govern, and secure control plane across all agents in the enterprise. The SDK is free and framework-agnostic - works with Microsoft Agent Framework, OpenAI Agents SDK, LangChain, Semantic Kernel. Brings custom and third-party agents under one governance umbrella so Day-2 visibility and policy enforcement are consistent</a:t>
+            </a:r>
+          </a:p>
+          <a:p>
+            <a:r>
+              <a:t>- The next two slides go deeper into incident response and model lifecycle</a:t>
             </a:r>
           </a:p>
         </p:txBody>
@@ -1512,17 +1450,32 @@
           <a:lstStyle/>
           <a:p>
             <a:r>
-              <a:t>- You do not need to boil the ocean. Start with one production-candidate agent and apply the four pillars end to end: evaluate it, ship it with evidence, observe it in production, and own the next improvement cycle</a:t>
-            </a:r>
-          </a:p>
-          <a:p>
-            <a:r>
-              <a:t>- Once the pattern is proven on one agent, it scales across the portfolio without re-litigating every decision</a:t>
-            </a:r>
-          </a:p>
-          <a:p>
-            <a:r>
-              <a:t>- Thank you - we are happy to take questions</a:t>
+              <a:t>- When something goes wrong in production, you need a structured response - not a fire drill. The runbook turns chaos into a sequence</a:t>
+            </a:r>
+          </a:p>
+          <a:p>
+            <a:r>
+              <a:t>- The severity table sets expectations so teams do not over-react or under-react</a:t>
+            </a:r>
+          </a:p>
+          <a:p>
+            <a:r>
+              <a:t>- The triage flow makes containment explicit - stop the bleed before debugging</a:t>
+            </a:r>
+          </a:p>
+          <a:p>
+            <a:r>
+              <a:t>- The runbook is part of Own because it turns production signals into containment, evidence-backed fixes, and future evaluation coverage</a:t>
+            </a:r>
+          </a:p>
+          <a:p>
+            <a:r>
+              <a:t>- Every closed incident produces evidence that updates the eval dataset, the gate criteria, or the operating model</a:t>
+            </a:r>
+          </a:p>
+          <a:p>
+            <a:r>
+              <a:t>- The other recurring Day-2 challenge is model lifecycle - let us look at that next</a:t>
             </a:r>
           </a:p>
         </p:txBody>
@@ -1592,7 +1545,7 @@
           <a:lstStyle/>
           <a:p>
             <a:r>
-              <a:t>- We have seven blocks to cover in fifty minutes - here is how we have structured the story</a:t>
+              <a:t>- We have six content blocks plus demos after each pillar - here is how we have structured the story</a:t>
             </a:r>
           </a:p>
           <a:p>
@@ -1602,17 +1555,12 @@
           </a:p>
           <a:p>
             <a:r>
-              <a:t>- Then a live demo showing the operating model on Foundry</a:t>
-            </a:r>
-          </a:p>
-          <a:p>
-            <a:r>
-              <a:t>- Then the four pillars themselves: evaluate, ship, observe, own</a:t>
-            </a:r>
-          </a:p>
-          <a:p>
-            <a:r>
-              <a:t>- We close with a practical 30-day adoption path</a:t>
+              <a:t>- Then the four pillars: evaluate, ship, observe, own - each followed by a live demo showing that pillar in action</a:t>
+            </a:r>
+          </a:p>
+          <a:p>
+            <a:r>
+              <a:t>- We close with your next steps to maturity</a:t>
             </a:r>
           </a:p>
           <a:p>
@@ -1692,6 +1640,266 @@
           <a:lstStyle/>
           <a:p>
             <a:r>
+              <a:t>- When the model itself changes - deprecation, new versions, cost pressure - that is model lifecycle. The recurring pain point: "the model we depend on is being deprecated, what now?"</a:t>
+            </a:r>
+          </a:p>
+          <a:p>
+            <a:r>
+              <a:t>- The answer: same gates and evidence as any other release candidate</a:t>
+            </a:r>
+          </a:p>
+          <a:p>
+            <a:r>
+              <a:t>- Triggers: deprecation, new model availability, cost or performance pressure, vendor change</a:t>
+            </a:r>
+          </a:p>
+          <a:p>
+            <a:r>
+              <a:t>- Canary process: pin current model as baseline; run new model against eval dataset offline; promote to canary traffic slice; compare live quality, cost, latency, safety; roll forward or roll back with evidence</a:t>
+            </a:r>
+          </a:p>
+          <a:p>
+            <a:r>
+              <a:t>- Ownership: AI platform team coordinates, application team validates</a:t>
+            </a:r>
+          </a:p>
+          <a:p>
+            <a:r>
+              <a:t>- Model lifecycle is part of Own because every model, prompt, or tool change becomes a new release candidate that must go back through Evaluate and Ship</a:t>
+            </a:r>
+          </a:p>
+          <a:p>
+            <a:r>
+              <a:t>- Canary upgrades map cleanly to model changes if the eval dataset and release contract are already in place</a:t>
+            </a:r>
+          </a:p>
+          <a:p>
+            <a:r>
+              <a:t>- We have covered the full loop - now the question is: where do you start?</a:t>
+            </a:r>
+          </a:p>
+        </p:txBody>
+      </p:sp>
+      <p:sp>
+        <p:nvSpPr>
+          <p:cNvPr id="4" name="Slide Number Placeholder 3"/>
+          <p:cNvSpPr>
+            <a:spLocks noGrp="1"/>
+          </p:cNvSpPr>
+          <p:nvPr>
+            <p:ph type="sldNum" idx="5" sz="quarter"/>
+          </p:nvPr>
+        </p:nvSpPr>
+        <p:spPr/>
+      </p:sp>
+    </p:spTree>
+  </p:cSld>
+  <p:clrMapOvr>
+    <a:masterClrMapping/>
+  </p:clrMapOvr>
+</p:notes>
+</file>
+
+<file path=ppt/notesSlides/notesSlide21.xml><?xml version="1.0" encoding="utf-8"?>
+<p:notes xmlns:a="http://schemas.openxmlformats.org/drawingml/2006/main" xmlns:p="http://schemas.openxmlformats.org/presentationml/2006/main" xmlns:r="http://schemas.openxmlformats.org/officeDocument/2006/relationships">
+  <p:cSld>
+    <p:spTree>
+      <p:nvGrpSpPr>
+        <p:cNvPr id="1" name=""/>
+        <p:cNvGrpSpPr/>
+        <p:nvPr/>
+      </p:nvGrpSpPr>
+      <p:grpSpPr>
+        <a:xfrm>
+          <a:off x="0" y="0"/>
+          <a:ext cx="0" cy="0"/>
+          <a:chOff x="0" y="0"/>
+          <a:chExt cx="0" cy="0"/>
+        </a:xfrm>
+      </p:grpSpPr>
+      <p:sp>
+        <p:nvSpPr>
+          <p:cNvPr id="2" name="Slide Image Placeholder 1"/>
+          <p:cNvSpPr>
+            <a:spLocks noGrp="1"/>
+          </p:cNvSpPr>
+          <p:nvPr>
+            <p:ph type="sldImg" idx="2"/>
+          </p:nvPr>
+        </p:nvSpPr>
+        <p:spPr/>
+      </p:sp>
+      <p:sp>
+        <p:nvSpPr>
+          <p:cNvPr id="3" name="Notes Placeholder 2"/>
+          <p:cNvSpPr>
+            <a:spLocks noGrp="1"/>
+          </p:cNvSpPr>
+          <p:nvPr>
+            <p:ph type="body" idx="3" sz="quarter"/>
+          </p:nvPr>
+        </p:nvSpPr>
+        <p:spPr/>
+        <p:txBody>
+          <a:bodyPr/>
+          <a:lstStyle/>
+          <a:p>
+            <a:r>
+              <a:t>- Live demo showing Day-2 operations: incident triage from trace, model canary comparison, and production learnings feeding back into the eval dataset</a:t>
+            </a:r>
+          </a:p>
+        </p:txBody>
+      </p:sp>
+      <p:sp>
+        <p:nvSpPr>
+          <p:cNvPr id="4" name="Slide Number Placeholder 3"/>
+          <p:cNvSpPr>
+            <a:spLocks noGrp="1"/>
+          </p:cNvSpPr>
+          <p:nvPr>
+            <p:ph type="sldNum" idx="5" sz="quarter"/>
+          </p:nvPr>
+        </p:nvSpPr>
+        <p:spPr/>
+      </p:sp>
+    </p:spTree>
+  </p:cSld>
+  <p:clrMapOvr>
+    <a:masterClrMapping/>
+  </p:clrMapOvr>
+</p:notes>
+</file>
+
+<file path=ppt/notesSlides/notesSlide22.xml><?xml version="1.0" encoding="utf-8"?>
+<p:notes xmlns:a="http://schemas.openxmlformats.org/drawingml/2006/main" xmlns:p="http://schemas.openxmlformats.org/presentationml/2006/main" xmlns:r="http://schemas.openxmlformats.org/officeDocument/2006/relationships">
+  <p:cSld>
+    <p:spTree>
+      <p:nvGrpSpPr>
+        <p:cNvPr id="1" name=""/>
+        <p:cNvGrpSpPr/>
+        <p:nvPr/>
+      </p:nvGrpSpPr>
+      <p:grpSpPr>
+        <a:xfrm>
+          <a:off x="0" y="0"/>
+          <a:ext cx="0" cy="0"/>
+          <a:chOff x="0" y="0"/>
+          <a:chExt cx="0" cy="0"/>
+        </a:xfrm>
+      </p:grpSpPr>
+      <p:sp>
+        <p:nvSpPr>
+          <p:cNvPr id="2" name="Slide Image Placeholder 1"/>
+          <p:cNvSpPr>
+            <a:spLocks noGrp="1"/>
+          </p:cNvSpPr>
+          <p:nvPr>
+            <p:ph type="sldImg" idx="2"/>
+          </p:nvPr>
+        </p:nvSpPr>
+        <p:spPr/>
+      </p:sp>
+      <p:sp>
+        <p:nvSpPr>
+          <p:cNvPr id="3" name="Notes Placeholder 2"/>
+          <p:cNvSpPr>
+            <a:spLocks noGrp="1"/>
+          </p:cNvSpPr>
+          <p:nvPr>
+            <p:ph type="body" idx="3" sz="quarter"/>
+          </p:nvPr>
+        </p:nvSpPr>
+        <p:spPr/>
+        <p:txBody>
+          <a:bodyPr/>
+          <a:lstStyle/>
+          <a:p>
+            <a:r>
+              <a:t>- You do not need to boil the ocean. Start with one production-candidate agent and apply the four pillars end to end</a:t>
+            </a:r>
+          </a:p>
+          <a:p>
+            <a:r>
+              <a:t>- Revisit the maturity model from earlier - identify where your team sits today (most are Initial or Defined) and set a concrete goal to reach the next level within 90 days</a:t>
+            </a:r>
+          </a:p>
+          <a:p>
+            <a:r>
+              <a:t>- Once the pattern is proven on one agent, it scales across the portfolio without re-litigating every decision</a:t>
+            </a:r>
+          </a:p>
+          <a:p>
+            <a:r>
+              <a:t>- The maturity model is not aspirational - it is a concrete checklist of what changes between levels</a:t>
+            </a:r>
+          </a:p>
+        </p:txBody>
+      </p:sp>
+      <p:sp>
+        <p:nvSpPr>
+          <p:cNvPr id="4" name="Slide Number Placeholder 3"/>
+          <p:cNvSpPr>
+            <a:spLocks noGrp="1"/>
+          </p:cNvSpPr>
+          <p:nvPr>
+            <p:ph type="sldNum" idx="5" sz="quarter"/>
+          </p:nvPr>
+        </p:nvSpPr>
+        <p:spPr/>
+      </p:sp>
+    </p:spTree>
+  </p:cSld>
+  <p:clrMapOvr>
+    <a:masterClrMapping/>
+  </p:clrMapOvr>
+</p:notes>
+</file>
+
+<file path=ppt/notesSlides/notesSlide23.xml><?xml version="1.0" encoding="utf-8"?>
+<p:notes xmlns:a="http://schemas.openxmlformats.org/drawingml/2006/main" xmlns:p="http://schemas.openxmlformats.org/presentationml/2006/main" xmlns:r="http://schemas.openxmlformats.org/officeDocument/2006/relationships">
+  <p:cSld>
+    <p:spTree>
+      <p:nvGrpSpPr>
+        <p:cNvPr id="1" name=""/>
+        <p:cNvGrpSpPr/>
+        <p:nvPr/>
+      </p:nvGrpSpPr>
+      <p:grpSpPr>
+        <a:xfrm>
+          <a:off x="0" y="0"/>
+          <a:ext cx="0" cy="0"/>
+          <a:chOff x="0" y="0"/>
+          <a:chExt cx="0" cy="0"/>
+        </a:xfrm>
+      </p:grpSpPr>
+      <p:sp>
+        <p:nvSpPr>
+          <p:cNvPr id="2" name="Slide Image Placeholder 1"/>
+          <p:cNvSpPr>
+            <a:spLocks noGrp="1"/>
+          </p:cNvSpPr>
+          <p:nvPr>
+            <p:ph type="sldImg" idx="2"/>
+          </p:nvPr>
+        </p:nvSpPr>
+        <p:spPr/>
+      </p:sp>
+      <p:sp>
+        <p:nvSpPr>
+          <p:cNvPr id="3" name="Notes Placeholder 2"/>
+          <p:cNvSpPr>
+            <a:spLocks noGrp="1"/>
+          </p:cNvSpPr>
+          <p:nvPr>
+            <p:ph type="body" idx="3" sz="quarter"/>
+          </p:nvPr>
+        </p:nvSpPr>
+        <p:spPr/>
+        <p:txBody>
+          <a:bodyPr/>
+          <a:lstStyle/>
+          <a:p>
+            <a:r>
               <a:t>- Thank you for your time today</a:t>
             </a:r>
           </a:p>
@@ -2377,7 +2585,7 @@
           </a:p>
           <a:p>
             <a:r>
-              <a:t>- Pipeline chips get stricter per environment: dev runs manual tests + quality evals + safety eval; qa adds integration tests + red team; prod runs smoke tests + blue/green + A/B tests (no re-eval - the evidence is locked at qa)</a:t>
+              <a:t>- Pipeline chips get stricter per environment: dev runs manual tests + quality evals + safety eval; qa adds integration tests + red team; prod runs smoke tests plus blue-green or canary rollout (no re-eval - the evidence is locked at qa)</a:t>
             </a:r>
           </a:p>
           <a:p>
@@ -5646,7 +5854,7 @@
                 </a:solidFill>
                 <a:latin typeface="Segoe UI Semibold"/>
               </a:rPr>
-              <a:t>Demo</a:t>
+              <a:t>Evaluate</a:t>
             </a:r>
           </a:p>
         </p:txBody>
@@ -5681,7 +5889,7 @@
                 </a:solidFill>
                 <a:latin typeface="Segoe UI"/>
               </a:rPr>
-              <a:t>Let's see this in action</a:t>
+              <a:t>The release signal for agentic systems</a:t>
             </a:r>
           </a:p>
         </p:txBody>
@@ -5712,8 +5920,8 @@
         </p:nvSpPr>
         <p:spPr>
           <a:xfrm>
-            <a:off x="584200" y="3079000"/>
-            <a:ext cx="11018838" cy="700000"/>
+            <a:off x="588263" y="457200"/>
+            <a:ext cx="11018520" cy="553998"/>
           </a:xfrm>
           <a:prstGeom prst="rect">
             <a:avLst/>
@@ -5726,15 +5934,14 @@
           </a:bodyPr>
           <a:lstStyle/>
           <a:p>
-            <a:pPr algn="l"/>
-            <a:r>
-              <a:rPr sz="3600" b="0">
+            <a:r>
+              <a:rPr sz="2800" b="0">
                 <a:solidFill>
                   <a:srgbClr val="091F2C"/>
                 </a:solidFill>
                 <a:latin typeface="Segoe UI Semibold"/>
               </a:rPr>
-              <a:t>Evaluate</a:t>
+              <a:t>Evaluation strategy</a:t>
             </a:r>
           </a:p>
         </p:txBody>
@@ -5747,8 +5954,8 @@
         </p:nvSpPr>
         <p:spPr>
           <a:xfrm>
-            <a:off x="584200" y="4240850"/>
-            <a:ext cx="11018838" cy="600000"/>
+            <a:off x="584200" y="1200000"/>
+            <a:ext cx="11018838" cy="350000"/>
           </a:xfrm>
           <a:prstGeom prst="rect">
             <a:avLst/>
@@ -5761,19 +5968,42 @@
           </a:bodyPr>
           <a:lstStyle/>
           <a:p>
-            <a:pPr algn="l"/>
-            <a:r>
-              <a:rPr sz="2200" b="0">
+            <a:r>
+              <a:rPr sz="1800" b="0">
                 <a:solidFill>
                   <a:srgbClr val="555555"/>
                 </a:solidFill>
                 <a:latin typeface="Segoe UI"/>
               </a:rPr>
-              <a:t>The release signal for agentic systems</a:t>
-            </a:r>
-          </a:p>
-        </p:txBody>
-      </p:sp>
+              <a:t>Evaluation is not a one-time score - it's the release signal that grows as production teaches you new failure modes</a:t>
+            </a:r>
+          </a:p>
+        </p:txBody>
+      </p:sp>
+      <p:pic>
+        <p:nvPicPr>
+          <p:cNvPr id="4" name="Three-stage evaluation timeline: base model selection, pre-production evaluation, post-production monitoring" descr="Three-stage evaluation timeline: base model selection, pre-production evaluation, post-production monitoring"/>
+          <p:cNvPicPr>
+            <a:picLocks noChangeAspect="1"/>
+          </p:cNvPicPr>
+          <p:nvPr/>
+        </p:nvPicPr>
+        <p:blipFill>
+          <a:blip r:embed="rId3"/>
+          <a:stretch>
+            <a:fillRect/>
+          </a:stretch>
+        </p:blipFill>
+        <p:spPr>
+          <a:xfrm>
+            <a:off x="1716308" y="2103120"/>
+            <a:ext cx="8759384" cy="4554880"/>
+          </a:xfrm>
+          <a:prstGeom prst="rect">
+            <a:avLst/>
+          </a:prstGeom>
+        </p:spPr>
+      </p:pic>
     </p:spTree>
   </p:cSld>
   <p:clrMapOvr>
@@ -5821,7 +6051,7 @@
                 </a:solidFill>
                 <a:latin typeface="Segoe UI Semibold"/>
               </a:rPr>
-              <a:t>Evaluation strategy</a:t>
+              <a:t>Red teaming and AI safety</a:t>
             </a:r>
           </a:p>
         </p:txBody>
@@ -5855,14 +6085,14 @@
                 </a:solidFill>
                 <a:latin typeface="Segoe UI"/>
               </a:rPr>
-              <a:t>Evaluation is not a one-time score - it's the release signal that grows as production teaches you new failure modes</a:t>
+              <a:t>Quality asks "is the answer good?" Red teaming asks "can someone make it misbehave?" Both are required</a:t>
             </a:r>
           </a:p>
         </p:txBody>
       </p:sp>
       <p:pic>
         <p:nvPicPr>
-          <p:cNvPr id="4" name="Three-stage evaluation timeline: base model selection, pre-production evaluation, post-production monitoring" descr="Three-stage evaluation timeline: base model selection, pre-production evaluation, post-production monitoring"/>
+          <p:cNvPr id="4" name="Red teaming taxonomy: four risk categories (harmful content, jailbreak, hallucination, data exfiltration) plus the four-step probe process" descr="Red teaming taxonomy: four risk categories (harmful content, jailbreak, hallucination, data exfiltration) plus the four-step probe process"/>
           <p:cNvPicPr>
             <a:picLocks noChangeAspect="1"/>
           </p:cNvPicPr>
@@ -5876,8 +6106,8 @@
         </p:blipFill>
         <p:spPr>
           <a:xfrm>
-            <a:off x="1716308" y="2103120"/>
-            <a:ext cx="8759384" cy="4554880"/>
+            <a:off x="1399687" y="2103120"/>
+            <a:ext cx="9392626" cy="4554880"/>
           </a:xfrm>
           <a:prstGeom prst="rect">
             <a:avLst/>
@@ -5910,8 +6140,8 @@
         </p:nvSpPr>
         <p:spPr>
           <a:xfrm>
-            <a:off x="588263" y="457200"/>
-            <a:ext cx="11018520" cy="553998"/>
+            <a:off x="584200" y="1500000"/>
+            <a:ext cx="11018838" cy="800000"/>
           </a:xfrm>
           <a:prstGeom prst="rect">
             <a:avLst/>
@@ -5924,14 +6154,15 @@
           </a:bodyPr>
           <a:lstStyle/>
           <a:p>
-            <a:r>
-              <a:rPr sz="2800" b="0">
-                <a:solidFill>
-                  <a:srgbClr val="091F2C"/>
+            <a:pPr algn="ctr"/>
+            <a:r>
+              <a:rPr sz="4800" b="0">
+                <a:solidFill>
+                  <a:srgbClr val="555555"/>
                 </a:solidFill>
                 <a:latin typeface="Segoe UI Semibold"/>
               </a:rPr>
-              <a:t>Red teaming and AI safety</a:t>
+              <a:t>DEMO</a:t>
             </a:r>
           </a:p>
         </p:txBody>
@@ -5944,8 +6175,8 @@
         </p:nvSpPr>
         <p:spPr>
           <a:xfrm>
-            <a:off x="584200" y="1200000"/>
-            <a:ext cx="11018838" cy="350000"/>
+            <a:off x="584200" y="2600000"/>
+            <a:ext cx="11018838" cy="900000"/>
           </a:xfrm>
           <a:prstGeom prst="rect">
             <a:avLst/>
@@ -5958,42 +6189,54 @@
           </a:bodyPr>
           <a:lstStyle/>
           <a:p>
-            <a:r>
-              <a:rPr sz="1800" b="0">
-                <a:solidFill>
-                  <a:srgbClr val="555555"/>
-                </a:solidFill>
-                <a:latin typeface="Segoe UI"/>
-              </a:rPr>
-              <a:t>Quality asks "is the answer good?" Red teaming asks "can someone make it misbehave?" Both are required</a:t>
-            </a:r>
-          </a:p>
-        </p:txBody>
-      </p:sp>
-      <p:pic>
-        <p:nvPicPr>
-          <p:cNvPr id="4" name="Red teaming taxonomy: four risk categories (harmful content, jailbreak, hallucination, data exfiltration) plus the four-step probe process" descr="Red teaming taxonomy: four risk categories (harmful content, jailbreak, hallucination, data exfiltration) plus the four-step probe process"/>
-          <p:cNvPicPr>
-            <a:picLocks noChangeAspect="1"/>
-          </p:cNvPicPr>
+            <a:pPr algn="ctr"/>
+            <a:r>
+              <a:rPr sz="5400" b="0">
+                <a:solidFill>
+                  <a:srgbClr val="091F2C"/>
+                </a:solidFill>
+                <a:latin typeface="Segoe UI Semibold"/>
+              </a:rPr>
+              <a:t>Evaluate</a:t>
+            </a:r>
+          </a:p>
+        </p:txBody>
+      </p:sp>
+      <p:sp>
+        <p:nvSpPr>
+          <p:cNvPr id="4" name="TextBox 3"/>
+          <p:cNvSpPr txBox="1"/>
           <p:nvPr/>
-        </p:nvPicPr>
-        <p:blipFill>
-          <a:blip r:embed="rId3"/>
-          <a:stretch>
-            <a:fillRect/>
-          </a:stretch>
-        </p:blipFill>
-        <p:spPr>
-          <a:xfrm>
-            <a:off x="1399687" y="2103120"/>
-            <a:ext cx="9392626" cy="4554880"/>
+        </p:nvSpPr>
+        <p:spPr>
+          <a:xfrm>
+            <a:off x="584200" y="5958000"/>
+            <a:ext cx="11018838" cy="500000"/>
           </a:xfrm>
           <a:prstGeom prst="rect">
             <a:avLst/>
           </a:prstGeom>
-        </p:spPr>
-      </p:pic>
+          <a:noFill/>
+        </p:spPr>
+        <p:txBody>
+          <a:bodyPr wrap="square">
+            <a:spAutoFit/>
+          </a:bodyPr>
+          <a:lstStyle/>
+          <a:p>
+            <a:pPr algn="ctr"/>
+            <a:r>
+              <a:rPr sz="1800" b="0">
+                <a:solidFill>
+                  <a:srgbClr val="555555"/>
+                </a:solidFill>
+                <a:latin typeface="Segoe UI"/>
+              </a:rPr>
+              <a:t>Paulo Lacerda, Senior Cloud Solution Architect, Microsoft</a:t>
+            </a:r>
+          </a:p>
+        </p:txBody>
+      </p:sp>
     </p:spTree>
   </p:cSld>
   <p:clrMapOvr>
@@ -6218,8 +6461,8 @@
         </p:nvSpPr>
         <p:spPr>
           <a:xfrm>
-            <a:off x="584200" y="3079000"/>
-            <a:ext cx="11018838" cy="700000"/>
+            <a:off x="584200" y="1500000"/>
+            <a:ext cx="11018838" cy="800000"/>
           </a:xfrm>
           <a:prstGeom prst="rect">
             <a:avLst/>
@@ -6232,15 +6475,15 @@
           </a:bodyPr>
           <a:lstStyle/>
           <a:p>
-            <a:pPr algn="l"/>
-            <a:r>
-              <a:rPr sz="3600" b="0">
-                <a:solidFill>
-                  <a:srgbClr val="091F2C"/>
+            <a:pPr algn="ctr"/>
+            <a:r>
+              <a:rPr sz="4800" b="0">
+                <a:solidFill>
+                  <a:srgbClr val="555555"/>
                 </a:solidFill>
                 <a:latin typeface="Segoe UI Semibold"/>
               </a:rPr>
-              <a:t>Observe</a:t>
+              <a:t>DEMO</a:t>
             </a:r>
           </a:p>
         </p:txBody>
@@ -6253,8 +6496,8 @@
         </p:nvSpPr>
         <p:spPr>
           <a:xfrm>
-            <a:off x="584200" y="4240850"/>
-            <a:ext cx="11018838" cy="600000"/>
+            <a:off x="584200" y="2600000"/>
+            <a:ext cx="11018838" cy="900000"/>
           </a:xfrm>
           <a:prstGeom prst="rect">
             <a:avLst/>
@@ -6267,15 +6510,50 @@
           </a:bodyPr>
           <a:lstStyle/>
           <a:p>
-            <a:pPr algn="l"/>
-            <a:r>
-              <a:rPr sz="2200" b="0">
+            <a:pPr algn="ctr"/>
+            <a:r>
+              <a:rPr sz="5400" b="0">
+                <a:solidFill>
+                  <a:srgbClr val="091F2C"/>
+                </a:solidFill>
+                <a:latin typeface="Segoe UI Semibold"/>
+              </a:rPr>
+              <a:t>Ship</a:t>
+            </a:r>
+          </a:p>
+        </p:txBody>
+      </p:sp>
+      <p:sp>
+        <p:nvSpPr>
+          <p:cNvPr id="4" name="TextBox 3"/>
+          <p:cNvSpPr txBox="1"/>
+          <p:nvPr/>
+        </p:nvSpPr>
+        <p:spPr>
+          <a:xfrm>
+            <a:off x="584200" y="5958000"/>
+            <a:ext cx="11018838" cy="500000"/>
+          </a:xfrm>
+          <a:prstGeom prst="rect">
+            <a:avLst/>
+          </a:prstGeom>
+          <a:noFill/>
+        </p:spPr>
+        <p:txBody>
+          <a:bodyPr wrap="square">
+            <a:spAutoFit/>
+          </a:bodyPr>
+          <a:lstStyle/>
+          <a:p>
+            <a:pPr algn="ctr"/>
+            <a:r>
+              <a:rPr sz="1800" b="0">
                 <a:solidFill>
                   <a:srgbClr val="555555"/>
                 </a:solidFill>
                 <a:latin typeface="Segoe UI"/>
               </a:rPr>
-              <a:t>Traces, correlation, and the closed loop</a:t>
+              <a:t>Paulo Lacerda, Senior Cloud Solution Architect, Microsoft</a:t>
             </a:r>
           </a:p>
         </p:txBody>
@@ -6306,8 +6584,8 @@
         </p:nvSpPr>
         <p:spPr>
           <a:xfrm>
-            <a:off x="588263" y="457200"/>
-            <a:ext cx="11018520" cy="553998"/>
+            <a:off x="584200" y="3079000"/>
+            <a:ext cx="11018838" cy="700000"/>
           </a:xfrm>
           <a:prstGeom prst="rect">
             <a:avLst/>
@@ -6320,14 +6598,15 @@
           </a:bodyPr>
           <a:lstStyle/>
           <a:p>
-            <a:r>
-              <a:rPr sz="2800" b="0">
+            <a:pPr algn="l"/>
+            <a:r>
+              <a:rPr sz="3600" b="0">
                 <a:solidFill>
                   <a:srgbClr val="091F2C"/>
                 </a:solidFill>
                 <a:latin typeface="Segoe UI Semibold"/>
               </a:rPr>
-              <a:t>Observability for agents is more than monitoring</a:t>
+              <a:t>Observe</a:t>
             </a:r>
           </a:p>
         </p:txBody>
@@ -6340,8 +6619,8 @@
         </p:nvSpPr>
         <p:spPr>
           <a:xfrm>
-            <a:off x="584200" y="1200000"/>
-            <a:ext cx="11018838" cy="350000"/>
+            <a:off x="584200" y="4240850"/>
+            <a:ext cx="11018838" cy="600000"/>
           </a:xfrm>
           <a:prstGeom prst="rect">
             <a:avLst/>
@@ -6354,42 +6633,19 @@
           </a:bodyPr>
           <a:lstStyle/>
           <a:p>
-            <a:r>
-              <a:rPr sz="1800" b="0">
+            <a:pPr algn="l"/>
+            <a:r>
+              <a:rPr sz="2200" b="0">
                 <a:solidFill>
                   <a:srgbClr val="555555"/>
                 </a:solidFill>
                 <a:latin typeface="Segoe UI"/>
               </a:rPr>
-              <a:t>Infrastructure monitoring asks "is the service healthy?" Agent observability asks "what did it do and why?"</a:t>
-            </a:r>
-          </a:p>
-        </p:txBody>
-      </p:sp>
-      <p:pic>
-        <p:nvPicPr>
-          <p:cNvPr id="4" name="Foundry observability stack with three pillars: tracing, monitoring, continuous evaluation" descr="Foundry observability stack with three pillars: tracing, monitoring, continuous evaluation"/>
-          <p:cNvPicPr>
-            <a:picLocks noChangeAspect="1"/>
-          </p:cNvPicPr>
-          <p:nvPr/>
-        </p:nvPicPr>
-        <p:blipFill>
-          <a:blip r:embed="rId3"/>
-          <a:stretch>
-            <a:fillRect/>
-          </a:stretch>
-        </p:blipFill>
-        <p:spPr>
-          <a:xfrm>
-            <a:off x="1716308" y="2103120"/>
-            <a:ext cx="8759384" cy="4554880"/>
-          </a:xfrm>
-          <a:prstGeom prst="rect">
-            <a:avLst/>
-          </a:prstGeom>
-        </p:spPr>
-      </p:pic>
+              <a:t>Traces, correlation, and the closed loop</a:t>
+            </a:r>
+          </a:p>
+        </p:txBody>
+      </p:sp>
     </p:spTree>
   </p:cSld>
   <p:clrMapOvr>
@@ -6437,7 +6693,7 @@
                 </a:solidFill>
                 <a:latin typeface="Segoe UI Semibold"/>
               </a:rPr>
-              <a:t>From telemetry to action</a:t>
+              <a:t>Observability for agents is more than monitoring</a:t>
             </a:r>
           </a:p>
         </p:txBody>
@@ -6471,14 +6727,14 @@
                 </a:solidFill>
                 <a:latin typeface="Segoe UI"/>
               </a:rPr>
-              <a:t>The end state is not a dashboard. The end state is action: observe, diagnose, improve, and ship the next version with evidence</a:t>
+              <a:t>Infrastructure monitoring asks "is the service healthy?" Agent observability asks "what did it do and why?"</a:t>
             </a:r>
           </a:p>
         </p:txBody>
       </p:sp>
       <p:pic>
         <p:nvPicPr>
-          <p:cNvPr id="4" name="Trace waterfall plus a signals-to-actions table showing how each telemetry signal triggers a concrete operational response" descr="Trace waterfall plus a signals-to-actions table showing how each telemetry signal triggers a concrete operational response"/>
+          <p:cNvPr id="4" name="Foundry observability stack with three pillars: tracing, monitoring, continuous evaluation" descr="Foundry observability stack with three pillars: tracing, monitoring, continuous evaluation"/>
           <p:cNvPicPr>
             <a:picLocks noChangeAspect="1"/>
           </p:cNvPicPr>
@@ -6492,8 +6748,8 @@
         </p:blipFill>
         <p:spPr>
           <a:xfrm>
-            <a:off x="1153085" y="2103120"/>
-            <a:ext cx="9885830" cy="4554880"/>
+            <a:off x="1716308" y="2103120"/>
+            <a:ext cx="8759384" cy="4554880"/>
           </a:xfrm>
           <a:prstGeom prst="rect">
             <a:avLst/>
@@ -6629,7 +6885,7 @@
                 </a:solidFill>
                 <a:latin typeface="Segoe UI"/>
               </a:rPr>
-              <a:t>Demo</a:t>
+              <a:t>Evaluate</a:t>
             </a:r>
             <a:r>
               <a:rPr sz="1600" b="0">
@@ -6638,7 +6894,7 @@
                 </a:solidFill>
                 <a:latin typeface="Segoe UI"/>
               </a:rPr>
-              <a:t> - the operating model in action on Foundry</a:t>
+              <a:t> - quality, grounding, behavior, and red teaming</a:t>
             </a:r>
           </a:p>
           <a:p>
@@ -6663,7 +6919,7 @@
                 </a:solidFill>
                 <a:latin typeface="Segoe UI"/>
               </a:rPr>
-              <a:t>Evaluate</a:t>
+              <a:t>Ship</a:t>
             </a:r>
             <a:r>
               <a:rPr sz="1600" b="0">
@@ -6672,7 +6928,7 @@
                 </a:solidFill>
                 <a:latin typeface="Segoe UI"/>
               </a:rPr>
-              <a:t> - quality, grounding, behavior, and red teaming</a:t>
+              <a:t> - gates, evidence, approvals, and environment promotion</a:t>
             </a:r>
           </a:p>
           <a:p>
@@ -6697,7 +6953,7 @@
                 </a:solidFill>
                 <a:latin typeface="Segoe UI"/>
               </a:rPr>
-              <a:t>Ship</a:t>
+              <a:t>Observe</a:t>
             </a:r>
             <a:r>
               <a:rPr sz="1600" b="0">
@@ -6706,7 +6962,7 @@
                 </a:solidFill>
                 <a:latin typeface="Segoe UI"/>
               </a:rPr>
-              <a:t> - gates, evidence, approvals, and environment promotion</a:t>
+              <a:t> - traces, correlation, telemetry, and feedback</a:t>
             </a:r>
           </a:p>
           <a:p>
@@ -6731,7 +6987,7 @@
                 </a:solidFill>
                 <a:latin typeface="Segoe UI"/>
               </a:rPr>
-              <a:t>Observe</a:t>
+              <a:t>Own</a:t>
             </a:r>
             <a:r>
               <a:rPr sz="1600" b="0">
@@ -6740,7 +6996,7 @@
                 </a:solidFill>
                 <a:latin typeface="Segoe UI"/>
               </a:rPr>
-              <a:t> - traces, correlation, telemetry, and feedback</a:t>
+              <a:t> - incident response, model lifecycle, cost, and capacity</a:t>
             </a:r>
           </a:p>
           <a:p>
@@ -6765,7 +7021,7 @@
                 </a:solidFill>
                 <a:latin typeface="Segoe UI"/>
               </a:rPr>
-              <a:t>Own</a:t>
+              <a:t>Your Next Steps</a:t>
             </a:r>
             <a:r>
               <a:rPr sz="1600" b="0">
@@ -6774,41 +7030,7 @@
                 </a:solidFill>
                 <a:latin typeface="Segoe UI"/>
               </a:rPr>
-              <a:t> - incident response, model lifecycle, cost, and capacity</a:t>
-            </a:r>
-          </a:p>
-          <a:p>
-            <a:pPr>
-              <a:spcAft>
-                <a:spcPts val="400"/>
-              </a:spcAft>
-            </a:pPr>
-            <a:r>
-              <a:rPr sz="1600">
-                <a:solidFill>
-                  <a:srgbClr val="091F2C"/>
-                </a:solidFill>
-                <a:latin typeface="Segoe UI"/>
-              </a:rPr>
-              <a:t>• </a:t>
-            </a:r>
-            <a:r>
-              <a:rPr sz="1600" b="1">
-                <a:solidFill>
-                  <a:srgbClr val="091F2C"/>
-                </a:solidFill>
-                <a:latin typeface="Segoe UI"/>
-              </a:rPr>
-              <a:t>Adoption</a:t>
-            </a:r>
-            <a:r>
-              <a:rPr sz="1600" b="0">
-                <a:solidFill>
-                  <a:srgbClr val="091F2C"/>
-                </a:solidFill>
-                <a:latin typeface="Segoe UI"/>
-              </a:rPr>
-              <a:t> - start with one production-candidate agent</a:t>
+              <a:t> - from where you are today to the next level of maturity</a:t>
             </a:r>
           </a:p>
         </p:txBody>
@@ -6839,8 +7061,8 @@
         </p:nvSpPr>
         <p:spPr>
           <a:xfrm>
-            <a:off x="584200" y="3079000"/>
-            <a:ext cx="11018838" cy="700000"/>
+            <a:off x="588263" y="457200"/>
+            <a:ext cx="11018520" cy="553998"/>
           </a:xfrm>
           <a:prstGeom prst="rect">
             <a:avLst/>
@@ -6853,15 +7075,14 @@
           </a:bodyPr>
           <a:lstStyle/>
           <a:p>
-            <a:pPr algn="l"/>
-            <a:r>
-              <a:rPr sz="3600" b="0">
+            <a:r>
+              <a:rPr sz="2800" b="0">
                 <a:solidFill>
                   <a:srgbClr val="091F2C"/>
                 </a:solidFill>
                 <a:latin typeface="Segoe UI Semibold"/>
               </a:rPr>
-              <a:t>Own</a:t>
+              <a:t>From telemetry to action</a:t>
             </a:r>
           </a:p>
         </p:txBody>
@@ -6874,8 +7095,8 @@
         </p:nvSpPr>
         <p:spPr>
           <a:xfrm>
-            <a:off x="584200" y="4240850"/>
-            <a:ext cx="11018838" cy="600000"/>
+            <a:off x="584200" y="1200000"/>
+            <a:ext cx="11018838" cy="350000"/>
           </a:xfrm>
           <a:prstGeom prst="rect">
             <a:avLst/>
@@ -6888,19 +7109,42 @@
           </a:bodyPr>
           <a:lstStyle/>
           <a:p>
-            <a:pPr algn="l"/>
-            <a:r>
-              <a:rPr sz="2200" b="0">
+            <a:r>
+              <a:rPr sz="1800" b="0">
                 <a:solidFill>
                   <a:srgbClr val="555555"/>
                 </a:solidFill>
                 <a:latin typeface="Segoe UI"/>
               </a:rPr>
-              <a:t>Running agents in production</a:t>
-            </a:r>
-          </a:p>
-        </p:txBody>
-      </p:sp>
+              <a:t>The end state is not a dashboard. The end state is action: observe, diagnose, improve, and ship the next version with evidence</a:t>
+            </a:r>
+          </a:p>
+        </p:txBody>
+      </p:sp>
+      <p:pic>
+        <p:nvPicPr>
+          <p:cNvPr id="4" name="Trace waterfall plus a signals-to-actions table showing how each telemetry signal triggers a concrete operational response" descr="Trace waterfall plus a signals-to-actions table showing how each telemetry signal triggers a concrete operational response"/>
+          <p:cNvPicPr>
+            <a:picLocks noChangeAspect="1"/>
+          </p:cNvPicPr>
+          <p:nvPr/>
+        </p:nvPicPr>
+        <p:blipFill>
+          <a:blip r:embed="rId3"/>
+          <a:stretch>
+            <a:fillRect/>
+          </a:stretch>
+        </p:blipFill>
+        <p:spPr>
+          <a:xfrm>
+            <a:off x="1153085" y="2103120"/>
+            <a:ext cx="9885830" cy="4554880"/>
+          </a:xfrm>
+          <a:prstGeom prst="rect">
+            <a:avLst/>
+          </a:prstGeom>
+        </p:spPr>
+      </p:pic>
     </p:spTree>
   </p:cSld>
   <p:clrMapOvr>
@@ -6927,6 +7171,217 @@
         </p:nvSpPr>
         <p:spPr>
           <a:xfrm>
+            <a:off x="584200" y="1500000"/>
+            <a:ext cx="11018838" cy="800000"/>
+          </a:xfrm>
+          <a:prstGeom prst="rect">
+            <a:avLst/>
+          </a:prstGeom>
+          <a:noFill/>
+        </p:spPr>
+        <p:txBody>
+          <a:bodyPr wrap="square">
+            <a:spAutoFit/>
+          </a:bodyPr>
+          <a:lstStyle/>
+          <a:p>
+            <a:pPr algn="ctr"/>
+            <a:r>
+              <a:rPr sz="4800" b="0">
+                <a:solidFill>
+                  <a:srgbClr val="555555"/>
+                </a:solidFill>
+                <a:latin typeface="Segoe UI Semibold"/>
+              </a:rPr>
+              <a:t>DEMO</a:t>
+            </a:r>
+          </a:p>
+        </p:txBody>
+      </p:sp>
+      <p:sp>
+        <p:nvSpPr>
+          <p:cNvPr id="3" name="TextBox 2"/>
+          <p:cNvSpPr txBox="1"/>
+          <p:nvPr/>
+        </p:nvSpPr>
+        <p:spPr>
+          <a:xfrm>
+            <a:off x="584200" y="2600000"/>
+            <a:ext cx="11018838" cy="900000"/>
+          </a:xfrm>
+          <a:prstGeom prst="rect">
+            <a:avLst/>
+          </a:prstGeom>
+          <a:noFill/>
+        </p:spPr>
+        <p:txBody>
+          <a:bodyPr wrap="square">
+            <a:spAutoFit/>
+          </a:bodyPr>
+          <a:lstStyle/>
+          <a:p>
+            <a:pPr algn="ctr"/>
+            <a:r>
+              <a:rPr sz="5400" b="0">
+                <a:solidFill>
+                  <a:srgbClr val="091F2C"/>
+                </a:solidFill>
+                <a:latin typeface="Segoe UI Semibold"/>
+              </a:rPr>
+              <a:t>Observe</a:t>
+            </a:r>
+          </a:p>
+        </p:txBody>
+      </p:sp>
+      <p:sp>
+        <p:nvSpPr>
+          <p:cNvPr id="4" name="TextBox 3"/>
+          <p:cNvSpPr txBox="1"/>
+          <p:nvPr/>
+        </p:nvSpPr>
+        <p:spPr>
+          <a:xfrm>
+            <a:off x="584200" y="5958000"/>
+            <a:ext cx="11018838" cy="500000"/>
+          </a:xfrm>
+          <a:prstGeom prst="rect">
+            <a:avLst/>
+          </a:prstGeom>
+          <a:noFill/>
+        </p:spPr>
+        <p:txBody>
+          <a:bodyPr wrap="square">
+            <a:spAutoFit/>
+          </a:bodyPr>
+          <a:lstStyle/>
+          <a:p>
+            <a:pPr algn="ctr"/>
+            <a:r>
+              <a:rPr sz="1800" b="0">
+                <a:solidFill>
+                  <a:srgbClr val="555555"/>
+                </a:solidFill>
+                <a:latin typeface="Segoe UI"/>
+              </a:rPr>
+              <a:t>Paulo Lacerda, Senior Cloud Solution Architect, Microsoft</a:t>
+            </a:r>
+          </a:p>
+        </p:txBody>
+      </p:sp>
+    </p:spTree>
+  </p:cSld>
+  <p:clrMapOvr>
+    <a:masterClrMapping/>
+  </p:clrMapOvr>
+</p:sld>
+</file>
+
+<file path=ppt/slides/slide22.xml><?xml version="1.0" encoding="utf-8"?>
+<p:sld xmlns:a="http://schemas.openxmlformats.org/drawingml/2006/main" xmlns:p="http://schemas.openxmlformats.org/presentationml/2006/main" xmlns:r="http://schemas.openxmlformats.org/officeDocument/2006/relationships">
+  <p:cSld>
+    <p:spTree>
+      <p:nvGrpSpPr>
+        <p:cNvPr id="1" name=""/>
+        <p:cNvGrpSpPr/>
+        <p:nvPr/>
+      </p:nvGrpSpPr>
+      <p:grpSpPr/>
+      <p:sp>
+        <p:nvSpPr>
+          <p:cNvPr id="2" name="TextBox 1"/>
+          <p:cNvSpPr txBox="1"/>
+          <p:nvPr/>
+        </p:nvSpPr>
+        <p:spPr>
+          <a:xfrm>
+            <a:off x="584200" y="3079000"/>
+            <a:ext cx="11018838" cy="700000"/>
+          </a:xfrm>
+          <a:prstGeom prst="rect">
+            <a:avLst/>
+          </a:prstGeom>
+          <a:noFill/>
+        </p:spPr>
+        <p:txBody>
+          <a:bodyPr wrap="square">
+            <a:spAutoFit/>
+          </a:bodyPr>
+          <a:lstStyle/>
+          <a:p>
+            <a:pPr algn="l"/>
+            <a:r>
+              <a:rPr sz="3600" b="0">
+                <a:solidFill>
+                  <a:srgbClr val="091F2C"/>
+                </a:solidFill>
+                <a:latin typeface="Segoe UI Semibold"/>
+              </a:rPr>
+              <a:t>Own</a:t>
+            </a:r>
+          </a:p>
+        </p:txBody>
+      </p:sp>
+      <p:sp>
+        <p:nvSpPr>
+          <p:cNvPr id="3" name="TextBox 2"/>
+          <p:cNvSpPr txBox="1"/>
+          <p:nvPr/>
+        </p:nvSpPr>
+        <p:spPr>
+          <a:xfrm>
+            <a:off x="584200" y="4240850"/>
+            <a:ext cx="11018838" cy="600000"/>
+          </a:xfrm>
+          <a:prstGeom prst="rect">
+            <a:avLst/>
+          </a:prstGeom>
+          <a:noFill/>
+        </p:spPr>
+        <p:txBody>
+          <a:bodyPr wrap="square">
+            <a:spAutoFit/>
+          </a:bodyPr>
+          <a:lstStyle/>
+          <a:p>
+            <a:pPr algn="l"/>
+            <a:r>
+              <a:rPr sz="2200" b="0">
+                <a:solidFill>
+                  <a:srgbClr val="555555"/>
+                </a:solidFill>
+                <a:latin typeface="Segoe UI"/>
+              </a:rPr>
+              <a:t>Running agents in production</a:t>
+            </a:r>
+          </a:p>
+        </p:txBody>
+      </p:sp>
+    </p:spTree>
+  </p:cSld>
+  <p:clrMapOvr>
+    <a:masterClrMapping/>
+  </p:clrMapOvr>
+</p:sld>
+</file>
+
+<file path=ppt/slides/slide23.xml><?xml version="1.0" encoding="utf-8"?>
+<p:sld xmlns:a="http://schemas.openxmlformats.org/drawingml/2006/main" xmlns:p="http://schemas.openxmlformats.org/presentationml/2006/main" xmlns:r="http://schemas.openxmlformats.org/officeDocument/2006/relationships">
+  <p:cSld>
+    <p:spTree>
+      <p:nvGrpSpPr>
+        <p:cNvPr id="1" name=""/>
+        <p:cNvGrpSpPr/>
+        <p:nvPr/>
+      </p:nvGrpSpPr>
+      <p:grpSpPr/>
+      <p:sp>
+        <p:nvSpPr>
+          <p:cNvPr id="2" name="TextBox 1"/>
+          <p:cNvSpPr txBox="1"/>
+          <p:nvPr/>
+        </p:nvSpPr>
+        <p:spPr>
+          <a:xfrm>
             <a:off x="588263" y="457200"/>
             <a:ext cx="11018520" cy="553998"/>
           </a:xfrm>
@@ -7019,7 +7474,7 @@
 </p:sld>
 </file>
 
-<file path=ppt/slides/slide22.xml><?xml version="1.0" encoding="utf-8"?>
+<file path=ppt/slides/slide24.xml><?xml version="1.0" encoding="utf-8"?>
 <p:sld xmlns:a="http://schemas.openxmlformats.org/drawingml/2006/main" xmlns:p="http://schemas.openxmlformats.org/presentationml/2006/main" xmlns:r="http://schemas.openxmlformats.org/officeDocument/2006/relationships">
   <p:cSld>
     <p:spTree>
@@ -7528,7 +7983,7 @@
 </p:sld>
 </file>
 
-<file path=ppt/slides/slide23.xml><?xml version="1.0" encoding="utf-8"?>
+<file path=ppt/slides/slide25.xml><?xml version="1.0" encoding="utf-8"?>
 <p:sld xmlns:a="http://schemas.openxmlformats.org/drawingml/2006/main" xmlns:p="http://schemas.openxmlformats.org/presentationml/2006/main" xmlns:r="http://schemas.openxmlformats.org/officeDocument/2006/relationships">
   <p:cSld>
     <p:spTree>
@@ -7638,7 +8093,7 @@
 </p:sld>
 </file>
 
-<file path=ppt/slides/slide24.xml><?xml version="1.0" encoding="utf-8"?>
+<file path=ppt/slides/slide26.xml><?xml version="1.0" encoding="utf-8"?>
 <p:sld xmlns:a="http://schemas.openxmlformats.org/drawingml/2006/main" xmlns:p="http://schemas.openxmlformats.org/presentationml/2006/main" xmlns:r="http://schemas.openxmlformats.org/officeDocument/2006/relationships">
   <p:cSld>
     <p:spTree>
@@ -7656,8 +8111,8 @@
         </p:nvSpPr>
         <p:spPr>
           <a:xfrm>
-            <a:off x="584200" y="3079000"/>
-            <a:ext cx="11018838" cy="700000"/>
+            <a:off x="584200" y="1500000"/>
+            <a:ext cx="11018838" cy="800000"/>
           </a:xfrm>
           <a:prstGeom prst="rect">
             <a:avLst/>
@@ -7670,15 +8125,15 @@
           </a:bodyPr>
           <a:lstStyle/>
           <a:p>
-            <a:pPr algn="l"/>
-            <a:r>
-              <a:rPr sz="3600" b="0">
-                <a:solidFill>
-                  <a:srgbClr val="091F2C"/>
+            <a:pPr algn="ctr"/>
+            <a:r>
+              <a:rPr sz="4800" b="0">
+                <a:solidFill>
+                  <a:srgbClr val="555555"/>
                 </a:solidFill>
                 <a:latin typeface="Segoe UI Semibold"/>
               </a:rPr>
-              <a:t>Adoption</a:t>
+              <a:t>DEMO</a:t>
             </a:r>
           </a:p>
         </p:txBody>
@@ -7691,8 +8146,8 @@
         </p:nvSpPr>
         <p:spPr>
           <a:xfrm>
-            <a:off x="584200" y="4240850"/>
-            <a:ext cx="11018838" cy="600000"/>
+            <a:off x="584200" y="2600000"/>
+            <a:ext cx="11018838" cy="900000"/>
           </a:xfrm>
           <a:prstGeom prst="rect">
             <a:avLst/>
@@ -7705,15 +8160,50 @@
           </a:bodyPr>
           <a:lstStyle/>
           <a:p>
-            <a:pPr algn="l"/>
-            <a:r>
-              <a:rPr sz="2200" b="0">
+            <a:pPr algn="ctr"/>
+            <a:r>
+              <a:rPr sz="5400" b="0">
+                <a:solidFill>
+                  <a:srgbClr val="091F2C"/>
+                </a:solidFill>
+                <a:latin typeface="Segoe UI Semibold"/>
+              </a:rPr>
+              <a:t>Own</a:t>
+            </a:r>
+          </a:p>
+        </p:txBody>
+      </p:sp>
+      <p:sp>
+        <p:nvSpPr>
+          <p:cNvPr id="4" name="TextBox 3"/>
+          <p:cNvSpPr txBox="1"/>
+          <p:nvPr/>
+        </p:nvSpPr>
+        <p:spPr>
+          <a:xfrm>
+            <a:off x="584200" y="5958000"/>
+            <a:ext cx="11018838" cy="500000"/>
+          </a:xfrm>
+          <a:prstGeom prst="rect">
+            <a:avLst/>
+          </a:prstGeom>
+          <a:noFill/>
+        </p:spPr>
+        <p:txBody>
+          <a:bodyPr wrap="square">
+            <a:spAutoFit/>
+          </a:bodyPr>
+          <a:lstStyle/>
+          <a:p>
+            <a:pPr algn="ctr"/>
+            <a:r>
+              <a:rPr sz="1800" b="0">
                 <a:solidFill>
                   <a:srgbClr val="555555"/>
                 </a:solidFill>
                 <a:latin typeface="Segoe UI"/>
               </a:rPr>
-              <a:t>Start small, build the pattern</a:t>
+              <a:t>Paulo Lacerda, Senior Cloud Solution Architect, Microsoft</a:t>
             </a:r>
           </a:p>
         </p:txBody>
@@ -7726,7 +8216,7 @@
 </p:sld>
 </file>
 
-<file path=ppt/slides/slide25.xml><?xml version="1.0" encoding="utf-8"?>
+<file path=ppt/slides/slide27.xml><?xml version="1.0" encoding="utf-8"?>
 <p:sld xmlns:a="http://schemas.openxmlformats.org/drawingml/2006/main" xmlns:p="http://schemas.openxmlformats.org/presentationml/2006/main" xmlns:r="http://schemas.openxmlformats.org/officeDocument/2006/relationships">
   <p:cSld>
     <p:spTree>
@@ -7744,8 +8234,8 @@
         </p:nvSpPr>
         <p:spPr>
           <a:xfrm>
-            <a:off x="588263" y="457200"/>
-            <a:ext cx="11018520" cy="553998"/>
+            <a:off x="584200" y="3079000"/>
+            <a:ext cx="11018838" cy="700000"/>
           </a:xfrm>
           <a:prstGeom prst="rect">
             <a:avLst/>
@@ -7758,14 +8248,15 @@
           </a:bodyPr>
           <a:lstStyle/>
           <a:p>
-            <a:r>
-              <a:rPr sz="2800" b="0">
+            <a:pPr algn="l"/>
+            <a:r>
+              <a:rPr sz="3600" b="0">
                 <a:solidFill>
                   <a:srgbClr val="091F2C"/>
                 </a:solidFill>
                 <a:latin typeface="Segoe UI Semibold"/>
               </a:rPr>
-              <a:t>Start with one production-candidate agent</a:t>
+              <a:t>Your Next Steps</a:t>
             </a:r>
           </a:p>
         </p:txBody>
@@ -7778,8 +8269,8 @@
         </p:nvSpPr>
         <p:spPr>
           <a:xfrm>
-            <a:off x="584200" y="1200000"/>
-            <a:ext cx="11018838" cy="350000"/>
+            <a:off x="584200" y="4240850"/>
+            <a:ext cx="11018838" cy="600000"/>
           </a:xfrm>
           <a:prstGeom prst="rect">
             <a:avLst/>
@@ -7792,232 +8283,15 @@
           </a:bodyPr>
           <a:lstStyle/>
           <a:p>
-            <a:r>
-              <a:rPr sz="1800" b="0">
+            <a:pPr algn="l"/>
+            <a:r>
+              <a:rPr sz="2200" b="0">
                 <a:solidFill>
                   <a:srgbClr val="555555"/>
                 </a:solidFill>
                 <a:latin typeface="Segoe UI"/>
               </a:rPr>
-              <a:t>Your 30-day goal - move one agent from "it works in testing", to "we can operate it safely"</a:t>
-            </a:r>
-          </a:p>
-        </p:txBody>
-      </p:sp>
-      <p:sp>
-        <p:nvSpPr>
-          <p:cNvPr id="4" name="TextBox 3"/>
-          <p:cNvSpPr txBox="1"/>
-          <p:nvPr/>
-        </p:nvSpPr>
-        <p:spPr>
-          <a:xfrm>
-            <a:off x="584200" y="2095500"/>
-            <a:ext cx="11018838" cy="4833938"/>
-          </a:xfrm>
-          <a:prstGeom prst="rect">
-            <a:avLst/>
-          </a:prstGeom>
-          <a:noFill/>
-        </p:spPr>
-        <p:txBody>
-          <a:bodyPr wrap="square">
-            <a:spAutoFit/>
-          </a:bodyPr>
-          <a:lstStyle/>
-          <a:p>
-            <a:pPr>
-              <a:spcAft>
-                <a:spcPts val="400"/>
-              </a:spcAft>
-            </a:pPr>
-            <a:r>
-              <a:rPr sz="1600">
-                <a:solidFill>
-                  <a:srgbClr val="091F2C"/>
-                </a:solidFill>
-                <a:latin typeface="Segoe UI"/>
-              </a:rPr>
-              <a:t>• </a:t>
-            </a:r>
-            <a:r>
-              <a:rPr sz="1600" b="1">
-                <a:solidFill>
-                  <a:srgbClr val="091F2C"/>
-                </a:solidFill>
-                <a:latin typeface="Segoe UI"/>
-              </a:rPr>
-              <a:t>Pick one agent</a:t>
-            </a:r>
-            <a:r>
-              <a:rPr sz="1600" b="0">
-                <a:solidFill>
-                  <a:srgbClr val="091F2C"/>
-                </a:solidFill>
-                <a:latin typeface="Segoe UI"/>
-              </a:rPr>
-              <a:t> that is close to production</a:t>
-            </a:r>
-          </a:p>
-          <a:p>
-            <a:pPr>
-              <a:spcAft>
-                <a:spcPts val="400"/>
-              </a:spcAft>
-            </a:pPr>
-            <a:r>
-              <a:rPr sz="1600">
-                <a:solidFill>
-                  <a:srgbClr val="091F2C"/>
-                </a:solidFill>
-                <a:latin typeface="Segoe UI"/>
-              </a:rPr>
-              <a:t>• </a:t>
-            </a:r>
-            <a:r>
-              <a:rPr sz="1600" b="1">
-                <a:solidFill>
-                  <a:srgbClr val="091F2C"/>
-                </a:solidFill>
-                <a:latin typeface="Segoe UI"/>
-              </a:rPr>
-              <a:t>Evaluate</a:t>
-            </a:r>
-            <a:r>
-              <a:rPr sz="1600" b="0">
-                <a:solidFill>
-                  <a:srgbClr val="091F2C"/>
-                </a:solidFill>
-                <a:latin typeface="Segoe UI"/>
-              </a:rPr>
-              <a:t> it with release criteria and a small eval dataset</a:t>
-            </a:r>
-          </a:p>
-          <a:p>
-            <a:pPr>
-              <a:spcAft>
-                <a:spcPts val="400"/>
-              </a:spcAft>
-            </a:pPr>
-            <a:r>
-              <a:rPr sz="1600">
-                <a:solidFill>
-                  <a:srgbClr val="091F2C"/>
-                </a:solidFill>
-                <a:latin typeface="Segoe UI"/>
-              </a:rPr>
-              <a:t>• </a:t>
-            </a:r>
-            <a:r>
-              <a:rPr sz="1600" b="1">
-                <a:solidFill>
-                  <a:srgbClr val="091F2C"/>
-                </a:solidFill>
-                <a:latin typeface="Segoe UI"/>
-              </a:rPr>
-              <a:t>Ship</a:t>
-            </a:r>
-            <a:r>
-              <a:rPr sz="1600" b="0">
-                <a:solidFill>
-                  <a:srgbClr val="091F2C"/>
-                </a:solidFill>
-                <a:latin typeface="Segoe UI"/>
-              </a:rPr>
-              <a:t> it with PR gates, deploy gates, and readiness evidence</a:t>
-            </a:r>
-          </a:p>
-          <a:p>
-            <a:pPr>
-              <a:spcAft>
-                <a:spcPts val="400"/>
-              </a:spcAft>
-            </a:pPr>
-            <a:r>
-              <a:rPr sz="1600">
-                <a:solidFill>
-                  <a:srgbClr val="091F2C"/>
-                </a:solidFill>
-                <a:latin typeface="Segoe UI"/>
-              </a:rPr>
-              <a:t>• </a:t>
-            </a:r>
-            <a:r>
-              <a:rPr sz="1600" b="1">
-                <a:solidFill>
-                  <a:srgbClr val="091F2C"/>
-                </a:solidFill>
-                <a:latin typeface="Segoe UI"/>
-              </a:rPr>
-              <a:t>Observe</a:t>
-            </a:r>
-            <a:r>
-              <a:rPr sz="1600" b="0">
-                <a:solidFill>
-                  <a:srgbClr val="091F2C"/>
-                </a:solidFill>
-                <a:latin typeface="Segoe UI"/>
-              </a:rPr>
-              <a:t> it with telemetry, traces, dashboards, and alerts</a:t>
-            </a:r>
-          </a:p>
-          <a:p>
-            <a:pPr>
-              <a:spcAft>
-                <a:spcPts val="400"/>
-              </a:spcAft>
-            </a:pPr>
-            <a:r>
-              <a:rPr sz="1600">
-                <a:solidFill>
-                  <a:srgbClr val="091F2C"/>
-                </a:solidFill>
-                <a:latin typeface="Segoe UI"/>
-              </a:rPr>
-              <a:t>• </a:t>
-            </a:r>
-            <a:r>
-              <a:rPr sz="1600" b="1">
-                <a:solidFill>
-                  <a:srgbClr val="091F2C"/>
-                </a:solidFill>
-                <a:latin typeface="Segoe UI"/>
-              </a:rPr>
-              <a:t>Own</a:t>
-            </a:r>
-            <a:r>
-              <a:rPr sz="1600" b="0">
-                <a:solidFill>
-                  <a:srgbClr val="091F2C"/>
-                </a:solidFill>
-                <a:latin typeface="Segoe UI"/>
-              </a:rPr>
-              <a:t> it with weekly evidence reviews and production learnings</a:t>
-            </a:r>
-          </a:p>
-          <a:p>
-            <a:pPr>
-              <a:spcAft>
-                <a:spcPts val="400"/>
-              </a:spcAft>
-            </a:pPr>
-            <a:r>
-              <a:rPr sz="1600">
-                <a:solidFill>
-                  <a:srgbClr val="091F2C"/>
-                </a:solidFill>
-                <a:latin typeface="Segoe UI"/>
-              </a:rPr>
-              <a:t>• </a:t>
-            </a:r>
-            <a:r>
-              <a:rPr sz="1600" b="0">
-                <a:solidFill>
-                  <a:srgbClr val="091F2C"/>
-                </a:solidFill>
-                <a:latin typeface="Segoe UI"/>
-              </a:rPr>
-              <a:t>Feed learnings back into the next evaluation cycle</a:t>
+              <a:t>From where you are today to the next level of maturity</a:t>
             </a:r>
           </a:p>
         </p:txBody>
@@ -8030,7 +8304,354 @@
 </p:sld>
 </file>
 
-<file path=ppt/slides/slide26.xml><?xml version="1.0" encoding="utf-8"?>
+<file path=ppt/slides/slide28.xml><?xml version="1.0" encoding="utf-8"?>
+<p:sld xmlns:a="http://schemas.openxmlformats.org/drawingml/2006/main" xmlns:p="http://schemas.openxmlformats.org/presentationml/2006/main" xmlns:r="http://schemas.openxmlformats.org/officeDocument/2006/relationships">
+  <p:cSld>
+    <p:spTree>
+      <p:nvGrpSpPr>
+        <p:cNvPr id="1" name=""/>
+        <p:cNvGrpSpPr/>
+        <p:nvPr/>
+      </p:nvGrpSpPr>
+      <p:grpSpPr/>
+      <p:sp>
+        <p:nvSpPr>
+          <p:cNvPr id="2" name="TextBox 1"/>
+          <p:cNvSpPr txBox="1"/>
+          <p:nvPr/>
+        </p:nvSpPr>
+        <p:spPr>
+          <a:xfrm>
+            <a:off x="588263" y="457200"/>
+            <a:ext cx="11018520" cy="553998"/>
+          </a:xfrm>
+          <a:prstGeom prst="rect">
+            <a:avLst/>
+          </a:prstGeom>
+          <a:noFill/>
+        </p:spPr>
+        <p:txBody>
+          <a:bodyPr wrap="square">
+            <a:spAutoFit/>
+          </a:bodyPr>
+          <a:lstStyle/>
+          <a:p>
+            <a:r>
+              <a:rPr sz="2800" b="0">
+                <a:solidFill>
+                  <a:srgbClr val="091F2C"/>
+                </a:solidFill>
+                <a:latin typeface="Segoe UI Semibold"/>
+              </a:rPr>
+              <a:t>Start with one production-candidate agent</a:t>
+            </a:r>
+          </a:p>
+        </p:txBody>
+      </p:sp>
+      <p:sp>
+        <p:nvSpPr>
+          <p:cNvPr id="3" name="TextBox 2"/>
+          <p:cNvSpPr txBox="1"/>
+          <p:nvPr/>
+        </p:nvSpPr>
+        <p:spPr>
+          <a:xfrm>
+            <a:off x="584200" y="1200000"/>
+            <a:ext cx="11018838" cy="350000"/>
+          </a:xfrm>
+          <a:prstGeom prst="rect">
+            <a:avLst/>
+          </a:prstGeom>
+          <a:noFill/>
+        </p:spPr>
+        <p:txBody>
+          <a:bodyPr wrap="square">
+            <a:spAutoFit/>
+          </a:bodyPr>
+          <a:lstStyle/>
+          <a:p>
+            <a:r>
+              <a:rPr sz="1800" b="0">
+                <a:solidFill>
+                  <a:srgbClr val="555555"/>
+                </a:solidFill>
+                <a:latin typeface="Segoe UI"/>
+              </a:rPr>
+              <a:t>Your 30-day goal - move one agent from "it works in testing", to "we can operate it safely"</a:t>
+            </a:r>
+          </a:p>
+        </p:txBody>
+      </p:sp>
+      <p:sp>
+        <p:nvSpPr>
+          <p:cNvPr id="4" name="TextBox 3"/>
+          <p:cNvSpPr txBox="1"/>
+          <p:nvPr/>
+        </p:nvSpPr>
+        <p:spPr>
+          <a:xfrm>
+            <a:off x="584200" y="2095500"/>
+            <a:ext cx="11018838" cy="4833938"/>
+          </a:xfrm>
+          <a:prstGeom prst="rect">
+            <a:avLst/>
+          </a:prstGeom>
+          <a:noFill/>
+        </p:spPr>
+        <p:txBody>
+          <a:bodyPr wrap="square">
+            <a:spAutoFit/>
+          </a:bodyPr>
+          <a:lstStyle/>
+          <a:p>
+            <a:pPr>
+              <a:spcAft>
+                <a:spcPts val="400"/>
+              </a:spcAft>
+            </a:pPr>
+            <a:r>
+              <a:rPr sz="1600">
+                <a:solidFill>
+                  <a:srgbClr val="091F2C"/>
+                </a:solidFill>
+                <a:latin typeface="Segoe UI"/>
+              </a:rPr>
+              <a:t>• </a:t>
+            </a:r>
+            <a:r>
+              <a:rPr sz="1600" b="1">
+                <a:solidFill>
+                  <a:srgbClr val="091F2C"/>
+                </a:solidFill>
+                <a:latin typeface="Segoe UI"/>
+              </a:rPr>
+              <a:t>Pick one agent</a:t>
+            </a:r>
+            <a:r>
+              <a:rPr sz="1600" b="0">
+                <a:solidFill>
+                  <a:srgbClr val="091F2C"/>
+                </a:solidFill>
+                <a:latin typeface="Segoe UI"/>
+              </a:rPr>
+              <a:t> that is close to production</a:t>
+            </a:r>
+          </a:p>
+          <a:p>
+            <a:pPr>
+              <a:spcAft>
+                <a:spcPts val="400"/>
+              </a:spcAft>
+            </a:pPr>
+            <a:r>
+              <a:rPr sz="1600">
+                <a:solidFill>
+                  <a:srgbClr val="091F2C"/>
+                </a:solidFill>
+                <a:latin typeface="Segoe UI"/>
+              </a:rPr>
+              <a:t>• </a:t>
+            </a:r>
+            <a:r>
+              <a:rPr sz="1600" b="1">
+                <a:solidFill>
+                  <a:srgbClr val="091F2C"/>
+                </a:solidFill>
+                <a:latin typeface="Segoe UI"/>
+              </a:rPr>
+              <a:t>Evaluate</a:t>
+            </a:r>
+            <a:r>
+              <a:rPr sz="1600" b="0">
+                <a:solidFill>
+                  <a:srgbClr val="091F2C"/>
+                </a:solidFill>
+                <a:latin typeface="Segoe UI"/>
+              </a:rPr>
+              <a:t> it with release criteria and a small eval dataset</a:t>
+            </a:r>
+          </a:p>
+          <a:p>
+            <a:pPr>
+              <a:spcAft>
+                <a:spcPts val="400"/>
+              </a:spcAft>
+            </a:pPr>
+            <a:r>
+              <a:rPr sz="1600">
+                <a:solidFill>
+                  <a:srgbClr val="091F2C"/>
+                </a:solidFill>
+                <a:latin typeface="Segoe UI"/>
+              </a:rPr>
+              <a:t>• </a:t>
+            </a:r>
+            <a:r>
+              <a:rPr sz="1600" b="1">
+                <a:solidFill>
+                  <a:srgbClr val="091F2C"/>
+                </a:solidFill>
+                <a:latin typeface="Segoe UI"/>
+              </a:rPr>
+              <a:t>Ship</a:t>
+            </a:r>
+            <a:r>
+              <a:rPr sz="1600" b="0">
+                <a:solidFill>
+                  <a:srgbClr val="091F2C"/>
+                </a:solidFill>
+                <a:latin typeface="Segoe UI"/>
+              </a:rPr>
+              <a:t> it with PR gates, deploy gates, and readiness evidence</a:t>
+            </a:r>
+          </a:p>
+          <a:p>
+            <a:pPr>
+              <a:spcAft>
+                <a:spcPts val="400"/>
+              </a:spcAft>
+            </a:pPr>
+            <a:r>
+              <a:rPr sz="1600">
+                <a:solidFill>
+                  <a:srgbClr val="091F2C"/>
+                </a:solidFill>
+                <a:latin typeface="Segoe UI"/>
+              </a:rPr>
+              <a:t>• </a:t>
+            </a:r>
+            <a:r>
+              <a:rPr sz="1600" b="1">
+                <a:solidFill>
+                  <a:srgbClr val="091F2C"/>
+                </a:solidFill>
+                <a:latin typeface="Segoe UI"/>
+              </a:rPr>
+              <a:t>Observe</a:t>
+            </a:r>
+            <a:r>
+              <a:rPr sz="1600" b="0">
+                <a:solidFill>
+                  <a:srgbClr val="091F2C"/>
+                </a:solidFill>
+                <a:latin typeface="Segoe UI"/>
+              </a:rPr>
+              <a:t> it with telemetry, traces, dashboards, and alerts</a:t>
+            </a:r>
+          </a:p>
+          <a:p>
+            <a:pPr>
+              <a:spcAft>
+                <a:spcPts val="400"/>
+              </a:spcAft>
+            </a:pPr>
+            <a:r>
+              <a:rPr sz="1600">
+                <a:solidFill>
+                  <a:srgbClr val="091F2C"/>
+                </a:solidFill>
+                <a:latin typeface="Segoe UI"/>
+              </a:rPr>
+              <a:t>• </a:t>
+            </a:r>
+            <a:r>
+              <a:rPr sz="1600" b="1">
+                <a:solidFill>
+                  <a:srgbClr val="091F2C"/>
+                </a:solidFill>
+                <a:latin typeface="Segoe UI"/>
+              </a:rPr>
+              <a:t>Own</a:t>
+            </a:r>
+            <a:r>
+              <a:rPr sz="1600" b="0">
+                <a:solidFill>
+                  <a:srgbClr val="091F2C"/>
+                </a:solidFill>
+                <a:latin typeface="Segoe UI"/>
+              </a:rPr>
+              <a:t> it with weekly evidence reviews and production learnings</a:t>
+            </a:r>
+          </a:p>
+          <a:p>
+            <a:pPr>
+              <a:spcAft>
+                <a:spcPts val="400"/>
+              </a:spcAft>
+            </a:pPr>
+            <a:r>
+              <a:rPr sz="1600">
+                <a:solidFill>
+                  <a:srgbClr val="091F2C"/>
+                </a:solidFill>
+                <a:latin typeface="Segoe UI"/>
+              </a:rPr>
+              <a:t>• </a:t>
+            </a:r>
+            <a:r>
+              <a:rPr sz="1600" b="1">
+                <a:solidFill>
+                  <a:srgbClr val="091F2C"/>
+                </a:solidFill>
+                <a:latin typeface="Segoe UI"/>
+              </a:rPr>
+              <a:t>Feed learnings</a:t>
+            </a:r>
+            <a:r>
+              <a:rPr sz="1600" b="0">
+                <a:solidFill>
+                  <a:srgbClr val="091F2C"/>
+                </a:solidFill>
+                <a:latin typeface="Segoe UI"/>
+              </a:rPr>
+              <a:t> back into the next evaluation cycle</a:t>
+            </a:r>
+          </a:p>
+          <a:p>
+            <a:pPr>
+              <a:spcAft>
+                <a:spcPts val="400"/>
+              </a:spcAft>
+            </a:pPr>
+            <a:r>
+              <a:rPr sz="1600">
+                <a:solidFill>
+                  <a:srgbClr val="091F2C"/>
+                </a:solidFill>
+                <a:latin typeface="Segoe UI"/>
+              </a:rPr>
+              <a:t>• </a:t>
+            </a:r>
+            <a:r>
+              <a:rPr sz="1600" b="1">
+                <a:solidFill>
+                  <a:srgbClr val="091F2C"/>
+                </a:solidFill>
+                <a:latin typeface="Segoe UI"/>
+              </a:rPr>
+              <a:t>Revisit the maturity model</a:t>
+            </a:r>
+            <a:r>
+              <a:rPr sz="1600" b="0">
+                <a:solidFill>
+                  <a:srgbClr val="091F2C"/>
+                </a:solidFill>
+                <a:latin typeface="Segoe UI"/>
+              </a:rPr>
+              <a:t> - set your goal to reach the next level within 90 days</a:t>
+            </a:r>
+          </a:p>
+        </p:txBody>
+      </p:sp>
+    </p:spTree>
+  </p:cSld>
+  <p:clrMapOvr>
+    <a:masterClrMapping/>
+  </p:clrMapOvr>
+</p:sld>
+</file>
+
+<file path=ppt/slides/slide29.xml><?xml version="1.0" encoding="utf-8"?>
 <p:sld xmlns:a="http://schemas.openxmlformats.org/drawingml/2006/main" xmlns:p="http://schemas.openxmlformats.org/presentationml/2006/main" xmlns:r="http://schemas.openxmlformats.org/officeDocument/2006/relationships">
   <p:cSld>
     <p:spTree>
@@ -8353,7 +8974,7 @@
                 </a:solidFill>
                 <a:latin typeface="Segoe UI"/>
               </a:rPr>
-              <a:t>Each tier adds components and complexity - a production agent manages all of these simultaneously</a:t>
+              <a:t>Each tier adds components and complexity - a production agent manages all these simultaneously</a:t>
             </a:r>
           </a:p>
         </p:txBody>

</xml_diff>

<commit_message>
Regenerate four-pillars diagram and slides.pptx with Operate label
Re-render after the Own->Operate rename so the four-pillar diagram PNG and the

PowerPoint deck match the rest of the workshop materials.

Co-authored-by: Copilot <223556219+Copilot@users.noreply.github.com>
</commit_message>
<xml_diff>
--- a/short/slides.pptx
+++ b/short/slides.pptx
@@ -1206,7 +1206,7 @@
           </a:p>
           <a:p>
             <a:r>
-              <a:t>- This is how Observe feeds Own, and how Own feeds the next Evaluate and Ship cycle</a:t>
+              <a:t>- This is how Observe feeds Operate, and how Operate feeds the next Evaluate and Ship cycle</a:t>
             </a:r>
           </a:p>
         </p:txBody>
@@ -1346,7 +1346,7 @@
           <a:lstStyle/>
           <a:p>
             <a:r>
-              <a:t>- This is the Own pillar. Shipping is not the finish line, it is where the real operational work begins. Day-2 has four concerns teams need to own</a:t>
+              <a:t>- This is the Operate pillar. Shipping is not the finish line, it is where the real operational work begins. Day-2 has four concerns teams need to manage</a:t>
             </a:r>
           </a:p>
           <a:p>
@@ -1466,7 +1466,7 @@
           </a:p>
           <a:p>
             <a:r>
-              <a:t>- The runbook is part of Own because it turns production signals into containment, evidence-backed fixes, and future evaluation coverage</a:t>
+              <a:t>- The runbook is part of Operate because it turns production signals into containment, evidence-backed fixes, and future evaluation coverage</a:t>
             </a:r>
           </a:p>
           <a:p>
@@ -1556,17 +1556,12 @@
           </a:p>
           <a:p>
             <a:r>
-              <a:t>- Then the four pillars: evaluate, ship, observe, own - each followed by a live demo showing that pillar in action</a:t>
+              <a:t>- Then the four pillars: evaluate, ship, observe, operate - each followed by a live demo showing that pillar in action</a:t>
             </a:r>
           </a:p>
           <a:p>
             <a:r>
               <a:t>- We close with your next steps to maturity</a:t>
-            </a:r>
-          </a:p>
-          <a:p>
-            <a:r>
-              <a:t>- Ten minutes reserved for Q&amp;A at the end</a:t>
             </a:r>
           </a:p>
           <a:p>
@@ -1666,7 +1661,7 @@
           </a:p>
           <a:p>
             <a:r>
-              <a:t>- Model lifecycle is part of Own because every model, prompt, or tool change becomes a new release candidate that must go back through Evaluate and Ship</a:t>
+              <a:t>- Model lifecycle is part of Operate because every model, prompt, or tool change becomes a new release candidate that must go back through Evaluate and Ship</a:t>
             </a:r>
           </a:p>
           <a:p>
@@ -1906,16 +1901,6 @@
           </a:p>
           <a:p>
             <a:r>
-              <a:t>- We have ten minutes for questions</a:t>
-            </a:r>
-          </a:p>
-          <a:p>
-            <a:r>
-              <a:t>- Happy to go deeper on any of the pillars - evaluation datasets, CI/CD gate design, observability correlation, or Day-2 operations</a:t>
-            </a:r>
-          </a:p>
-          <a:p>
-            <a:r>
               <a:t>- If you want to continue the conversation, reach out to your account team or find us after the session</a:t>
             </a:r>
           </a:p>
@@ -2066,7 +2051,7 @@
           </a:p>
           <a:p>
             <a:r>
-              <a:t>- Production introduces new operational risk: quality, safety, monitoring, cost, ownership, and release confidence</a:t>
+              <a:t>- Production introduces new operational risk: quality, safety, monitoring, cost, operations, and release confidence</a:t>
             </a:r>
           </a:p>
           <a:p>
@@ -2466,7 +2451,7 @@
           </a:p>
           <a:p>
             <a:r>
-              <a:t>- Own the workload through diagnosis, incident response, runbooks, model lifecycle, cost management, capacity management, and continuous improvement</a:t>
+              <a:t>- Operate the workload through diagnosis, incident response, runbooks, model lifecycle, cost management, capacity management, and continuous improvement</a:t>
             </a:r>
           </a:p>
           <a:p>
@@ -7063,7 +7048,7 @@
                 </a:solidFill>
                 <a:latin typeface="Segoe UI"/>
               </a:rPr>
-              <a:t>Own</a:t>
+              <a:t>Operate</a:t>
             </a:r>
             <a:r>
               <a:rPr sz="1600" b="0">
@@ -7392,7 +7377,7 @@
                 </a:solidFill>
                 <a:latin typeface="Segoe UI Semibold"/>
               </a:rPr>
-              <a:t>Own</a:t>
+              <a:t>Operate</a:t>
             </a:r>
           </a:p>
         </p:txBody>
@@ -8244,7 +8229,7 @@
                 </a:solidFill>
                 <a:latin typeface="Segoe UI Semibold"/>
               </a:rPr>
-              <a:t>Own</a:t>
+              <a:t>Operate</a:t>
             </a:r>
           </a:p>
         </p:txBody>
@@ -8637,7 +8622,7 @@
                 </a:solidFill>
                 <a:latin typeface="Segoe UI"/>
               </a:rPr>
-              <a:t>Own</a:t>
+              <a:t>Operate</a:t>
             </a:r>
             <a:r>
               <a:rPr sz="1600" b="0">
@@ -8767,42 +8752,7 @@
                 </a:solidFill>
                 <a:latin typeface="Segoe UI Semibold"/>
               </a:rPr>
-              <a:t>Thank You</a:t>
-            </a:r>
-          </a:p>
-        </p:txBody>
-      </p:sp>
-      <p:sp>
-        <p:nvSpPr>
-          <p:cNvPr id="3" name="TextBox 2"/>
-          <p:cNvSpPr txBox="1"/>
-          <p:nvPr/>
-        </p:nvSpPr>
-        <p:spPr>
-          <a:xfrm>
-            <a:off x="584200" y="4240850"/>
-            <a:ext cx="11018838" cy="600000"/>
-          </a:xfrm>
-          <a:prstGeom prst="rect">
-            <a:avLst/>
-          </a:prstGeom>
-          <a:noFill/>
-        </p:spPr>
-        <p:txBody>
-          <a:bodyPr wrap="square">
-            <a:spAutoFit/>
-          </a:bodyPr>
-          <a:lstStyle/>
-          <a:p>
-            <a:pPr algn="l"/>
-            <a:r>
-              <a:rPr sz="2200" b="0">
-                <a:solidFill>
-                  <a:srgbClr val="555555"/>
-                </a:solidFill>
-                <a:latin typeface="Segoe UI"/>
-              </a:rPr>
-              <a:t>Questions and Discussion</a:t>
+              <a:t>Thank You!</a:t>
             </a:r>
           </a:p>
         </p:txBody>
@@ -10071,14 +10021,14 @@
                 </a:solidFill>
                 <a:latin typeface="Segoe UI"/>
               </a:rPr>
-              <a:t>Four pillars - Evaluate, ship, observe, and own production agents</a:t>
+              <a:t>Four pillars - Evaluate, ship, observe, and operate production agents</a:t>
             </a:r>
           </a:p>
         </p:txBody>
       </p:sp>
       <p:pic>
         <p:nvPicPr>
-          <p:cNvPr id="4" name="Four AgentOps pillars: Evaluate, Ship, Observe, Own, with example practices under each pillar" descr="Four AgentOps pillars: Evaluate, Ship, Observe, Own, with example practices under each pillar"/>
+          <p:cNvPr id="4" name="Four AgentOps pillars: Evaluate, Ship, Observe, Operate, with example practices under each pillar" descr="Four AgentOps pillars: Evaluate, Ship, Observe, Operate, with example practices under each pillar"/>
           <p:cNvPicPr>
             <a:picLocks noChangeAspect="1"/>
           </p:cNvPicPr>

</xml_diff>